<commit_message>
File re-org and cleanup
</commit_message>
<xml_diff>
--- a/slides/Installing the Courseware.pptx
+++ b/slides/Installing the Courseware.pptx
@@ -30,8 +30,8 @@
     <p:sldId id="1100" r:id="rId18"/>
     <p:sldId id="1101" r:id="rId19"/>
     <p:sldId id="1095" r:id="rId20"/>
-    <p:sldId id="1096" r:id="rId21"/>
-    <p:sldId id="1115" r:id="rId22"/>
+    <p:sldId id="1144" r:id="rId21"/>
+    <p:sldId id="1147" r:id="rId22"/>
     <p:sldId id="1140" r:id="rId23"/>
     <p:sldId id="1104" r:id="rId24"/>
     <p:sldId id="1133" r:id="rId25"/>
@@ -39,16 +39,16 @@
     <p:sldId id="1105" r:id="rId27"/>
     <p:sldId id="1107" r:id="rId28"/>
     <p:sldId id="1118" r:id="rId29"/>
-    <p:sldId id="1119" r:id="rId30"/>
-    <p:sldId id="1120" r:id="rId31"/>
+    <p:sldId id="1145" r:id="rId30"/>
+    <p:sldId id="1148" r:id="rId31"/>
     <p:sldId id="1098" r:id="rId32"/>
     <p:sldId id="1137" r:id="rId33"/>
     <p:sldId id="1110" r:id="rId34"/>
     <p:sldId id="1111" r:id="rId35"/>
     <p:sldId id="1112" r:id="rId36"/>
     <p:sldId id="1121" r:id="rId37"/>
-    <p:sldId id="1122" r:id="rId38"/>
-    <p:sldId id="1123" r:id="rId39"/>
+    <p:sldId id="1146" r:id="rId38"/>
+    <p:sldId id="1149" r:id="rId39"/>
     <p:sldId id="1141" r:id="rId40"/>
     <p:sldId id="933" r:id="rId41"/>
     <p:sldId id="1125" r:id="rId42"/>
@@ -249,7 +249,7 @@
           <a:p>
             <a:fld id="{A241AC98-512A-4A35-865E-757B6C1F07A2}" type="datetimeFigureOut">
               <a:rPr lang="en-US" smtClean="0"/>
-              <a:t>3/1/2022</a:t>
+              <a:t>3/3/2022</a:t>
             </a:fld>
             <a:endParaRPr lang="en-US"/>
           </a:p>
@@ -415,7 +415,7 @@
           <a:p>
             <a:fld id="{3854CEE7-15DE-41D9-8CA2-D1E137B1D850}" type="datetimeFigureOut">
               <a:rPr lang="en-US" smtClean="0"/>
-              <a:t>3/1/2022</a:t>
+              <a:t>3/3/2022</a:t>
             </a:fld>
             <a:endParaRPr lang="en-US"/>
           </a:p>
@@ -814,7 +814,7 @@
           <a:p>
             <a:fld id="{5555EB2C-244D-4423-AD97-018ED6478B87}" type="datetime1">
               <a:rPr lang="en-US" smtClean="0"/>
-              <a:t>3/1/2022</a:t>
+              <a:t>3/3/2022</a:t>
             </a:fld>
             <a:endParaRPr lang="en-US"/>
           </a:p>
@@ -993,7 +993,7 @@
           <a:p>
             <a:fld id="{A2B41D1F-7576-4C60-B4EB-5115BC56CF40}" type="datetime1">
               <a:rPr lang="en-US" smtClean="0"/>
-              <a:t>3/1/2022</a:t>
+              <a:t>3/3/2022</a:t>
             </a:fld>
             <a:endParaRPr lang="en-US"/>
           </a:p>
@@ -1185,7 +1185,7 @@
           <a:p>
             <a:fld id="{E79D1398-4D56-44F9-BA35-34ACF3159A64}" type="datetime1">
               <a:rPr lang="en-US" smtClean="0"/>
-              <a:t>3/1/2022</a:t>
+              <a:t>3/3/2022</a:t>
             </a:fld>
             <a:endParaRPr lang="en-US"/>
           </a:p>
@@ -1367,7 +1367,7 @@
           <a:p>
             <a:fld id="{A3CF632E-48CB-4EEB-A6B6-DEC7AD7CC976}" type="datetime1">
               <a:rPr lang="en-US" smtClean="0"/>
-              <a:t>3/1/2022</a:t>
+              <a:t>3/3/2022</a:t>
             </a:fld>
             <a:endParaRPr lang="en-US"/>
           </a:p>
@@ -1620,7 +1620,7 @@
           <a:p>
             <a:fld id="{BAEEE52C-3A57-458E-95F6-96B2FA9D1DD4}" type="datetime1">
               <a:rPr lang="en-US" smtClean="0"/>
-              <a:t>3/1/2022</a:t>
+              <a:t>3/3/2022</a:t>
             </a:fld>
             <a:endParaRPr lang="en-US"/>
           </a:p>
@@ -1864,7 +1864,7 @@
           <a:p>
             <a:fld id="{766FC747-A48A-4FF2-8EE4-3E95ECD1C2A8}" type="datetime1">
               <a:rPr lang="en-US" smtClean="0"/>
-              <a:t>3/1/2022</a:t>
+              <a:t>3/3/2022</a:t>
             </a:fld>
             <a:endParaRPr lang="en-US"/>
           </a:p>
@@ -2243,7 +2243,7 @@
           <a:p>
             <a:fld id="{C9BF5758-AB7F-463D-B638-E1729B95E126}" type="datetime1">
               <a:rPr lang="en-US" smtClean="0"/>
-              <a:t>3/1/2022</a:t>
+              <a:t>3/3/2022</a:t>
             </a:fld>
             <a:endParaRPr lang="en-US"/>
           </a:p>
@@ -2373,7 +2373,7 @@
           <a:p>
             <a:fld id="{F3718C77-7DD0-4738-BF52-D0EC9F78A76E}" type="datetime1">
               <a:rPr lang="en-US" smtClean="0"/>
-              <a:t>3/1/2022</a:t>
+              <a:t>3/3/2022</a:t>
             </a:fld>
             <a:endParaRPr lang="en-US"/>
           </a:p>
@@ -2480,7 +2480,7 @@
           <a:p>
             <a:fld id="{948970CF-13D9-4E1D-A74F-2CFE4953FCDB}" type="datetime1">
               <a:rPr lang="en-US" smtClean="0"/>
-              <a:t>3/1/2022</a:t>
+              <a:t>3/3/2022</a:t>
             </a:fld>
             <a:endParaRPr lang="en-US"/>
           </a:p>
@@ -2769,7 +2769,7 @@
           <a:p>
             <a:fld id="{F68C49B9-4E1C-4967-B9CF-0BF9FECBE837}" type="datetime1">
               <a:rPr lang="en-US" smtClean="0"/>
-              <a:t>3/1/2022</a:t>
+              <a:t>3/3/2022</a:t>
             </a:fld>
             <a:endParaRPr lang="en-US"/>
           </a:p>
@@ -3037,7 +3037,7 @@
           <a:p>
             <a:fld id="{7E338CBB-1F06-4333-9BBF-66628B15E581}" type="datetime1">
               <a:rPr lang="en-US" smtClean="0"/>
-              <a:t>3/1/2022</a:t>
+              <a:t>3/3/2022</a:t>
             </a:fld>
             <a:endParaRPr lang="en-US"/>
           </a:p>
@@ -3262,7 +3262,7 @@
           <a:p>
             <a:fld id="{705EC883-F03C-4CA3-AF62-BEF30EEA4F65}" type="datetime1">
               <a:rPr lang="en-US" smtClean="0"/>
-              <a:t>3/1/2022</a:t>
+              <a:t>3/3/2022</a:t>
             </a:fld>
             <a:endParaRPr lang="en-US"/>
           </a:p>
@@ -4477,10 +4477,10 @@
       </p:sp>
       <p:pic>
         <p:nvPicPr>
-          <p:cNvPr id="5" name="Picture 4">
+          <p:cNvPr id="8" name="Picture 7">
             <a:extLst>
               <a:ext uri="{FF2B5EF4-FFF2-40B4-BE49-F238E27FC236}">
-                <a16:creationId xmlns:a16="http://schemas.microsoft.com/office/drawing/2014/main" id="{D975D8D7-3E6C-46A3-8B76-629B284F0810}"/>
+                <a16:creationId xmlns:a16="http://schemas.microsoft.com/office/drawing/2014/main" id="{41FAFF94-5791-4651-A6A6-2B955BB40F74}"/>
               </a:ext>
             </a:extLst>
           </p:cNvPr>
@@ -4497,8 +4497,8 @@
         </p:blipFill>
         <p:spPr>
           <a:xfrm>
-            <a:off x="1843428" y="1771829"/>
-            <a:ext cx="5457143" cy="4123809"/>
+            <a:off x="1819619" y="1807704"/>
+            <a:ext cx="5504762" cy="4209524"/>
           </a:xfrm>
           <a:prstGeom prst="rect">
             <a:avLst/>
@@ -4535,6 +4535,41 @@
           <a:chExt cx="0" cy="0"/>
         </a:xfrm>
       </p:grpSpPr>
+      <p:pic>
+        <p:nvPicPr>
+          <p:cNvPr id="7" name="Picture 6">
+            <a:extLst>
+              <a:ext uri="{FF2B5EF4-FFF2-40B4-BE49-F238E27FC236}">
+                <a16:creationId xmlns:a16="http://schemas.microsoft.com/office/drawing/2014/main" id="{2A75CC74-F6B0-4379-9909-2DCCFB06535C}"/>
+              </a:ext>
+            </a:extLst>
+          </p:cNvPr>
+          <p:cNvPicPr>
+            <a:picLocks noChangeAspect="1"/>
+          </p:cNvPicPr>
+          <p:nvPr/>
+        </p:nvPicPr>
+        <p:blipFill>
+          <a:blip r:embed="rId2"/>
+          <a:stretch>
+            <a:fillRect/>
+          </a:stretch>
+        </p:blipFill>
+        <p:spPr>
+          <a:xfrm>
+            <a:off x="1514116" y="1277644"/>
+            <a:ext cx="6115767" cy="5261269"/>
+          </a:xfrm>
+          <a:prstGeom prst="rect">
+            <a:avLst/>
+          </a:prstGeom>
+          <a:ln>
+            <a:solidFill>
+              <a:schemeClr val="tx1"/>
+            </a:solidFill>
+          </a:ln>
+        </p:spPr>
+      </p:pic>
       <p:sp>
         <p:nvSpPr>
           <p:cNvPr id="2" name="Title 1"/>
@@ -4598,89 +4633,6 @@
       </p:sp>
       <p:sp>
         <p:nvSpPr>
-          <p:cNvPr id="21" name="Speech Bubble: Rectangle with Corners Rounded 20">
-            <a:extLst>
-              <a:ext uri="{FF2B5EF4-FFF2-40B4-BE49-F238E27FC236}">
-                <a16:creationId xmlns:a16="http://schemas.microsoft.com/office/drawing/2014/main" id="{FB70542E-CE07-4024-91C9-32200E403BE1}"/>
-              </a:ext>
-            </a:extLst>
-          </p:cNvPr>
-          <p:cNvSpPr/>
-          <p:nvPr/>
-        </p:nvSpPr>
-        <p:spPr>
-          <a:xfrm>
-            <a:off x="2083633" y="2572036"/>
-            <a:ext cx="1611442" cy="575898"/>
-          </a:xfrm>
-          <a:prstGeom prst="wedgeRoundRectCallout">
-            <a:avLst>
-              <a:gd name="adj1" fmla="val 116841"/>
-              <a:gd name="adj2" fmla="val -126212"/>
-              <a:gd name="adj3" fmla="val 16667"/>
-            </a:avLst>
-          </a:prstGeom>
-        </p:spPr>
-        <p:style>
-          <a:lnRef idx="2">
-            <a:schemeClr val="accent1">
-              <a:shade val="50000"/>
-            </a:schemeClr>
-          </a:lnRef>
-          <a:fillRef idx="1">
-            <a:schemeClr val="accent1"/>
-          </a:fillRef>
-          <a:effectRef idx="0">
-            <a:schemeClr val="accent1"/>
-          </a:effectRef>
-          <a:fontRef idx="minor">
-            <a:schemeClr val="lt1"/>
-          </a:fontRef>
-        </p:style>
-        <p:txBody>
-          <a:bodyPr rtlCol="0" anchor="ctr"/>
-          <a:lstStyle/>
-          <a:p>
-            <a:pPr algn="ctr"/>
-            <a:r>
-              <a:rPr lang="en-US" dirty="0"/>
-              <a:t>Click the "Run" button </a:t>
-            </a:r>
-          </a:p>
-        </p:txBody>
-      </p:sp>
-      <p:pic>
-        <p:nvPicPr>
-          <p:cNvPr id="3" name="Picture 2">
-            <a:extLst>
-              <a:ext uri="{FF2B5EF4-FFF2-40B4-BE49-F238E27FC236}">
-                <a16:creationId xmlns:a16="http://schemas.microsoft.com/office/drawing/2014/main" id="{4490DC95-9A99-41E5-8A0E-B374F7BB50F2}"/>
-              </a:ext>
-            </a:extLst>
-          </p:cNvPr>
-          <p:cNvPicPr>
-            <a:picLocks noChangeAspect="1"/>
-          </p:cNvPicPr>
-          <p:nvPr/>
-        </p:nvPicPr>
-        <p:blipFill>
-          <a:blip r:embed="rId2"/>
-          <a:stretch>
-            <a:fillRect/>
-          </a:stretch>
-        </p:blipFill>
-        <p:spPr>
-          <a:xfrm>
-            <a:off x="1235612" y="1315571"/>
-            <a:ext cx="6672775" cy="5325071"/>
-          </a:xfrm>
-          <a:prstGeom prst="rect">
-            <a:avLst/>
-          </a:prstGeom>
-        </p:spPr>
-      </p:pic>
-      <p:sp>
-        <p:nvSpPr>
           <p:cNvPr id="5" name="Rectangle 4">
             <a:extLst>
               <a:ext uri="{FF2B5EF4-FFF2-40B4-BE49-F238E27FC236}">
@@ -4693,7 +4645,7 @@
         </p:nvSpPr>
         <p:spPr>
           <a:xfrm>
-            <a:off x="1420249" y="4886793"/>
+            <a:off x="1757528" y="4939258"/>
             <a:ext cx="689548" cy="202368"/>
           </a:xfrm>
           <a:prstGeom prst="rect">
@@ -4745,7 +4697,7 @@
         </p:nvSpPr>
         <p:spPr>
           <a:xfrm>
-            <a:off x="2227289" y="3147934"/>
+            <a:off x="2564568" y="3200399"/>
             <a:ext cx="2725712" cy="1347859"/>
           </a:xfrm>
           <a:prstGeom prst="wedgeRoundRectCallout">
@@ -9516,7 +9468,7 @@
             </a:pPr>
             <a:r>
               <a:rPr lang="en-US" sz="2400" dirty="0"/>
-              <a:t>To properly setup a local Python development environment on your school computer, we will use free &amp; open-source tools like </a:t>
+              <a:t>To properly setup a local Python development environment on your computer, we will use free &amp; open-source tools like </a:t>
             </a:r>
             <a:r>
               <a:rPr lang="en-US" sz="2400" dirty="0">
@@ -9553,7 +9505,7 @@
             </a:pPr>
             <a:r>
               <a:rPr lang="en-US" sz="2400" dirty="0"/>
-              <a:t>If you already have these applications on your PC/laptop, you may not need to reinstall them, but please ensure you are running </a:t>
+              <a:t>If you already have these applications on your computer, you may not need to reinstall them, but please ensure you are running </a:t>
             </a:r>
             <a:r>
               <a:rPr lang="en-US" sz="2400" b="1" dirty="0">
@@ -9598,7 +9550,7 @@
             </a:r>
             <a:r>
               <a:rPr lang="en-US" sz="2400" dirty="0"/>
-              <a:t> distribution on your PC, you </a:t>
+              <a:t> distribution on your computer, you </a:t>
             </a:r>
             <a:r>
               <a:rPr lang="en-US" sz="2400" b="1" dirty="0">
@@ -9916,10 +9868,10 @@
       </p:sp>
       <p:pic>
         <p:nvPicPr>
-          <p:cNvPr id="5" name="Picture 4">
+          <p:cNvPr id="8" name="Picture 7">
             <a:extLst>
               <a:ext uri="{FF2B5EF4-FFF2-40B4-BE49-F238E27FC236}">
-                <a16:creationId xmlns:a16="http://schemas.microsoft.com/office/drawing/2014/main" id="{D975D8D7-3E6C-46A3-8B76-629B284F0810}"/>
+                <a16:creationId xmlns:a16="http://schemas.microsoft.com/office/drawing/2014/main" id="{41FAFF94-5791-4651-A6A6-2B955BB40F74}"/>
               </a:ext>
             </a:extLst>
           </p:cNvPr>
@@ -9936,8 +9888,8 @@
         </p:blipFill>
         <p:spPr>
           <a:xfrm>
-            <a:off x="1843428" y="1771829"/>
-            <a:ext cx="5457143" cy="4123809"/>
+            <a:off x="1819619" y="1807704"/>
+            <a:ext cx="5504762" cy="4209524"/>
           </a:xfrm>
           <a:prstGeom prst="rect">
             <a:avLst/>
@@ -9947,7 +9899,7 @@
     </p:spTree>
     <p:extLst>
       <p:ext uri="{BB962C8B-B14F-4D97-AF65-F5344CB8AC3E}">
-        <p14:creationId xmlns:p14="http://schemas.microsoft.com/office/powerpoint/2010/main" val="2229931630"/>
+        <p14:creationId xmlns:p14="http://schemas.microsoft.com/office/powerpoint/2010/main" val="2960588173"/>
       </p:ext>
     </p:extLst>
   </p:cSld>
@@ -9974,6 +9926,41 @@
           <a:chExt cx="0" cy="0"/>
         </a:xfrm>
       </p:grpSpPr>
+      <p:pic>
+        <p:nvPicPr>
+          <p:cNvPr id="7" name="Picture 6">
+            <a:extLst>
+              <a:ext uri="{FF2B5EF4-FFF2-40B4-BE49-F238E27FC236}">
+                <a16:creationId xmlns:a16="http://schemas.microsoft.com/office/drawing/2014/main" id="{2A75CC74-F6B0-4379-9909-2DCCFB06535C}"/>
+              </a:ext>
+            </a:extLst>
+          </p:cNvPr>
+          <p:cNvPicPr>
+            <a:picLocks noChangeAspect="1"/>
+          </p:cNvPicPr>
+          <p:nvPr/>
+        </p:nvPicPr>
+        <p:blipFill>
+          <a:blip r:embed="rId2"/>
+          <a:stretch>
+            <a:fillRect/>
+          </a:stretch>
+        </p:blipFill>
+        <p:spPr>
+          <a:xfrm>
+            <a:off x="1514116" y="1277644"/>
+            <a:ext cx="6115767" cy="5261269"/>
+          </a:xfrm>
+          <a:prstGeom prst="rect">
+            <a:avLst/>
+          </a:prstGeom>
+          <a:ln>
+            <a:solidFill>
+              <a:schemeClr val="tx1"/>
+            </a:solidFill>
+          </a:ln>
+        </p:spPr>
+      </p:pic>
       <p:sp>
         <p:nvSpPr>
           <p:cNvPr id="2" name="Title 1"/>
@@ -10037,89 +10024,6 @@
       </p:sp>
       <p:sp>
         <p:nvSpPr>
-          <p:cNvPr id="21" name="Speech Bubble: Rectangle with Corners Rounded 20">
-            <a:extLst>
-              <a:ext uri="{FF2B5EF4-FFF2-40B4-BE49-F238E27FC236}">
-                <a16:creationId xmlns:a16="http://schemas.microsoft.com/office/drawing/2014/main" id="{FB70542E-CE07-4024-91C9-32200E403BE1}"/>
-              </a:ext>
-            </a:extLst>
-          </p:cNvPr>
-          <p:cNvSpPr/>
-          <p:nvPr/>
-        </p:nvSpPr>
-        <p:spPr>
-          <a:xfrm>
-            <a:off x="2083633" y="2572036"/>
-            <a:ext cx="1611442" cy="575898"/>
-          </a:xfrm>
-          <a:prstGeom prst="wedgeRoundRectCallout">
-            <a:avLst>
-              <a:gd name="adj1" fmla="val 116841"/>
-              <a:gd name="adj2" fmla="val -126212"/>
-              <a:gd name="adj3" fmla="val 16667"/>
-            </a:avLst>
-          </a:prstGeom>
-        </p:spPr>
-        <p:style>
-          <a:lnRef idx="2">
-            <a:schemeClr val="accent1">
-              <a:shade val="50000"/>
-            </a:schemeClr>
-          </a:lnRef>
-          <a:fillRef idx="1">
-            <a:schemeClr val="accent1"/>
-          </a:fillRef>
-          <a:effectRef idx="0">
-            <a:schemeClr val="accent1"/>
-          </a:effectRef>
-          <a:fontRef idx="minor">
-            <a:schemeClr val="lt1"/>
-          </a:fontRef>
-        </p:style>
-        <p:txBody>
-          <a:bodyPr rtlCol="0" anchor="ctr"/>
-          <a:lstStyle/>
-          <a:p>
-            <a:pPr algn="ctr"/>
-            <a:r>
-              <a:rPr lang="en-US" dirty="0"/>
-              <a:t>Click the "Run" button </a:t>
-            </a:r>
-          </a:p>
-        </p:txBody>
-      </p:sp>
-      <p:pic>
-        <p:nvPicPr>
-          <p:cNvPr id="3" name="Picture 2">
-            <a:extLst>
-              <a:ext uri="{FF2B5EF4-FFF2-40B4-BE49-F238E27FC236}">
-                <a16:creationId xmlns:a16="http://schemas.microsoft.com/office/drawing/2014/main" id="{4490DC95-9A99-41E5-8A0E-B374F7BB50F2}"/>
-              </a:ext>
-            </a:extLst>
-          </p:cNvPr>
-          <p:cNvPicPr>
-            <a:picLocks noChangeAspect="1"/>
-          </p:cNvPicPr>
-          <p:nvPr/>
-        </p:nvPicPr>
-        <p:blipFill>
-          <a:blip r:embed="rId2"/>
-          <a:stretch>
-            <a:fillRect/>
-          </a:stretch>
-        </p:blipFill>
-        <p:spPr>
-          <a:xfrm>
-            <a:off x="1235612" y="1315571"/>
-            <a:ext cx="6672775" cy="5325071"/>
-          </a:xfrm>
-          <a:prstGeom prst="rect">
-            <a:avLst/>
-          </a:prstGeom>
-        </p:spPr>
-      </p:pic>
-      <p:sp>
-        <p:nvSpPr>
           <p:cNvPr id="5" name="Rectangle 4">
             <a:extLst>
               <a:ext uri="{FF2B5EF4-FFF2-40B4-BE49-F238E27FC236}">
@@ -10132,7 +10036,7 @@
         </p:nvSpPr>
         <p:spPr>
           <a:xfrm>
-            <a:off x="1420249" y="4886793"/>
+            <a:off x="1757528" y="4939258"/>
             <a:ext cx="689548" cy="202368"/>
           </a:xfrm>
           <a:prstGeom prst="rect">
@@ -10184,7 +10088,7 @@
         </p:nvSpPr>
         <p:spPr>
           <a:xfrm>
-            <a:off x="2227289" y="3147934"/>
+            <a:off x="2564568" y="3200399"/>
             <a:ext cx="2725712" cy="1347859"/>
           </a:xfrm>
           <a:prstGeom prst="wedgeRoundRectCallout">
@@ -10226,7 +10130,7 @@
     </p:spTree>
     <p:extLst>
       <p:ext uri="{BB962C8B-B14F-4D97-AF65-F5344CB8AC3E}">
-        <p14:creationId xmlns:p14="http://schemas.microsoft.com/office/powerpoint/2010/main" val="3067021287"/>
+        <p14:creationId xmlns:p14="http://schemas.microsoft.com/office/powerpoint/2010/main" val="355237893"/>
       </p:ext>
     </p:extLst>
   </p:cSld>
@@ -14212,10 +14116,10 @@
       </p:sp>
       <p:pic>
         <p:nvPicPr>
-          <p:cNvPr id="5" name="Picture 4">
+          <p:cNvPr id="8" name="Picture 7">
             <a:extLst>
               <a:ext uri="{FF2B5EF4-FFF2-40B4-BE49-F238E27FC236}">
-                <a16:creationId xmlns:a16="http://schemas.microsoft.com/office/drawing/2014/main" id="{D975D8D7-3E6C-46A3-8B76-629B284F0810}"/>
+                <a16:creationId xmlns:a16="http://schemas.microsoft.com/office/drawing/2014/main" id="{41FAFF94-5791-4651-A6A6-2B955BB40F74}"/>
               </a:ext>
             </a:extLst>
           </p:cNvPr>
@@ -14232,8 +14136,8 @@
         </p:blipFill>
         <p:spPr>
           <a:xfrm>
-            <a:off x="1843428" y="1771829"/>
-            <a:ext cx="5457143" cy="4123809"/>
+            <a:off x="1819619" y="1807704"/>
+            <a:ext cx="5504762" cy="4209524"/>
           </a:xfrm>
           <a:prstGeom prst="rect">
             <a:avLst/>
@@ -14243,7 +14147,7 @@
     </p:spTree>
     <p:extLst>
       <p:ext uri="{BB962C8B-B14F-4D97-AF65-F5344CB8AC3E}">
-        <p14:creationId xmlns:p14="http://schemas.microsoft.com/office/powerpoint/2010/main" val="3727760199"/>
+        <p14:creationId xmlns:p14="http://schemas.microsoft.com/office/powerpoint/2010/main" val="3193366687"/>
       </p:ext>
     </p:extLst>
   </p:cSld>
@@ -14351,7 +14255,7 @@
               <a:rPr lang="en-US" sz="2400" dirty="0">
                 <a:hlinkClick r:id="rId2" action="ppaction://hlinksldjump"/>
               </a:rPr>
-              <a:t>slide # 5</a:t>
+              <a:t>slide # 4</a:t>
             </a:r>
             <a:endParaRPr lang="en-US" sz="2400" dirty="0"/>
           </a:p>
@@ -14383,7 +14287,7 @@
               <a:rPr lang="en-US" sz="2400" dirty="0">
                 <a:hlinkClick r:id="rId3" action="ppaction://hlinksldjump"/>
               </a:rPr>
-              <a:t>slide # 14</a:t>
+              <a:t>slide # 13</a:t>
             </a:r>
             <a:endParaRPr lang="en-US" sz="2400" dirty="0"/>
           </a:p>
@@ -14415,7 +14319,7 @@
               <a:rPr lang="en-US" sz="2400" dirty="0">
                 <a:hlinkClick r:id="rId4" action="ppaction://hlinksldjump"/>
               </a:rPr>
-              <a:t>slide # 24</a:t>
+              <a:t>slide # 23</a:t>
             </a:r>
             <a:endParaRPr lang="en-US" sz="2400" dirty="0"/>
           </a:p>
@@ -14447,7 +14351,7 @@
               <a:rPr lang="en-US" sz="2400" dirty="0">
                 <a:hlinkClick r:id="rId5" action="ppaction://hlinksldjump"/>
               </a:rPr>
-              <a:t>slide # 32</a:t>
+              <a:t>slide # 31</a:t>
             </a:r>
             <a:endParaRPr lang="en-US" sz="2400" dirty="0"/>
           </a:p>
@@ -14902,6 +14806,41 @@
           <a:chExt cx="0" cy="0"/>
         </a:xfrm>
       </p:grpSpPr>
+      <p:pic>
+        <p:nvPicPr>
+          <p:cNvPr id="7" name="Picture 6">
+            <a:extLst>
+              <a:ext uri="{FF2B5EF4-FFF2-40B4-BE49-F238E27FC236}">
+                <a16:creationId xmlns:a16="http://schemas.microsoft.com/office/drawing/2014/main" id="{2A75CC74-F6B0-4379-9909-2DCCFB06535C}"/>
+              </a:ext>
+            </a:extLst>
+          </p:cNvPr>
+          <p:cNvPicPr>
+            <a:picLocks noChangeAspect="1"/>
+          </p:cNvPicPr>
+          <p:nvPr/>
+        </p:nvPicPr>
+        <p:blipFill>
+          <a:blip r:embed="rId2"/>
+          <a:stretch>
+            <a:fillRect/>
+          </a:stretch>
+        </p:blipFill>
+        <p:spPr>
+          <a:xfrm>
+            <a:off x="1514116" y="1277644"/>
+            <a:ext cx="6115767" cy="5261269"/>
+          </a:xfrm>
+          <a:prstGeom prst="rect">
+            <a:avLst/>
+          </a:prstGeom>
+          <a:ln>
+            <a:solidFill>
+              <a:schemeClr val="tx1"/>
+            </a:solidFill>
+          </a:ln>
+        </p:spPr>
+      </p:pic>
       <p:sp>
         <p:nvSpPr>
           <p:cNvPr id="2" name="Title 1"/>
@@ -14965,89 +14904,6 @@
       </p:sp>
       <p:sp>
         <p:nvSpPr>
-          <p:cNvPr id="21" name="Speech Bubble: Rectangle with Corners Rounded 20">
-            <a:extLst>
-              <a:ext uri="{FF2B5EF4-FFF2-40B4-BE49-F238E27FC236}">
-                <a16:creationId xmlns:a16="http://schemas.microsoft.com/office/drawing/2014/main" id="{FB70542E-CE07-4024-91C9-32200E403BE1}"/>
-              </a:ext>
-            </a:extLst>
-          </p:cNvPr>
-          <p:cNvSpPr/>
-          <p:nvPr/>
-        </p:nvSpPr>
-        <p:spPr>
-          <a:xfrm>
-            <a:off x="2083633" y="2572036"/>
-            <a:ext cx="1611442" cy="575898"/>
-          </a:xfrm>
-          <a:prstGeom prst="wedgeRoundRectCallout">
-            <a:avLst>
-              <a:gd name="adj1" fmla="val 116841"/>
-              <a:gd name="adj2" fmla="val -126212"/>
-              <a:gd name="adj3" fmla="val 16667"/>
-            </a:avLst>
-          </a:prstGeom>
-        </p:spPr>
-        <p:style>
-          <a:lnRef idx="2">
-            <a:schemeClr val="accent1">
-              <a:shade val="50000"/>
-            </a:schemeClr>
-          </a:lnRef>
-          <a:fillRef idx="1">
-            <a:schemeClr val="accent1"/>
-          </a:fillRef>
-          <a:effectRef idx="0">
-            <a:schemeClr val="accent1"/>
-          </a:effectRef>
-          <a:fontRef idx="minor">
-            <a:schemeClr val="lt1"/>
-          </a:fontRef>
-        </p:style>
-        <p:txBody>
-          <a:bodyPr rtlCol="0" anchor="ctr"/>
-          <a:lstStyle/>
-          <a:p>
-            <a:pPr algn="ctr"/>
-            <a:r>
-              <a:rPr lang="en-US" dirty="0"/>
-              <a:t>Click the "Run" button </a:t>
-            </a:r>
-          </a:p>
-        </p:txBody>
-      </p:sp>
-      <p:pic>
-        <p:nvPicPr>
-          <p:cNvPr id="3" name="Picture 2">
-            <a:extLst>
-              <a:ext uri="{FF2B5EF4-FFF2-40B4-BE49-F238E27FC236}">
-                <a16:creationId xmlns:a16="http://schemas.microsoft.com/office/drawing/2014/main" id="{4490DC95-9A99-41E5-8A0E-B374F7BB50F2}"/>
-              </a:ext>
-            </a:extLst>
-          </p:cNvPr>
-          <p:cNvPicPr>
-            <a:picLocks noChangeAspect="1"/>
-          </p:cNvPicPr>
-          <p:nvPr/>
-        </p:nvPicPr>
-        <p:blipFill>
-          <a:blip r:embed="rId2"/>
-          <a:stretch>
-            <a:fillRect/>
-          </a:stretch>
-        </p:blipFill>
-        <p:spPr>
-          <a:xfrm>
-            <a:off x="1235612" y="1315571"/>
-            <a:ext cx="6672775" cy="5325071"/>
-          </a:xfrm>
-          <a:prstGeom prst="rect">
-            <a:avLst/>
-          </a:prstGeom>
-        </p:spPr>
-      </p:pic>
-      <p:sp>
-        <p:nvSpPr>
           <p:cNvPr id="5" name="Rectangle 4">
             <a:extLst>
               <a:ext uri="{FF2B5EF4-FFF2-40B4-BE49-F238E27FC236}">
@@ -15060,7 +14916,7 @@
         </p:nvSpPr>
         <p:spPr>
           <a:xfrm>
-            <a:off x="1420249" y="4886793"/>
+            <a:off x="1757528" y="4939258"/>
             <a:ext cx="689548" cy="202368"/>
           </a:xfrm>
           <a:prstGeom prst="rect">
@@ -15112,7 +14968,7 @@
         </p:nvSpPr>
         <p:spPr>
           <a:xfrm>
-            <a:off x="2227289" y="3147934"/>
+            <a:off x="2564568" y="3200399"/>
             <a:ext cx="2725712" cy="1347859"/>
           </a:xfrm>
           <a:prstGeom prst="wedgeRoundRectCallout">
@@ -15154,7 +15010,7 @@
     </p:spTree>
     <p:extLst>
       <p:ext uri="{BB962C8B-B14F-4D97-AF65-F5344CB8AC3E}">
-        <p14:creationId xmlns:p14="http://schemas.microsoft.com/office/powerpoint/2010/main" val="3775873614"/>
+        <p14:creationId xmlns:p14="http://schemas.microsoft.com/office/powerpoint/2010/main" val="482405479"/>
       </p:ext>
     </p:extLst>
   </p:cSld>
@@ -18751,10 +18607,10 @@
       </p:sp>
       <p:pic>
         <p:nvPicPr>
-          <p:cNvPr id="5" name="Picture 4">
+          <p:cNvPr id="8" name="Picture 7">
             <a:extLst>
               <a:ext uri="{FF2B5EF4-FFF2-40B4-BE49-F238E27FC236}">
-                <a16:creationId xmlns:a16="http://schemas.microsoft.com/office/drawing/2014/main" id="{D975D8D7-3E6C-46A3-8B76-629B284F0810}"/>
+                <a16:creationId xmlns:a16="http://schemas.microsoft.com/office/drawing/2014/main" id="{41FAFF94-5791-4651-A6A6-2B955BB40F74}"/>
               </a:ext>
             </a:extLst>
           </p:cNvPr>
@@ -18771,8 +18627,8 @@
         </p:blipFill>
         <p:spPr>
           <a:xfrm>
-            <a:off x="1843428" y="1771829"/>
-            <a:ext cx="5457143" cy="4123809"/>
+            <a:off x="1819619" y="1807704"/>
+            <a:ext cx="5504762" cy="4209524"/>
           </a:xfrm>
           <a:prstGeom prst="rect">
             <a:avLst/>
@@ -18782,7 +18638,7 @@
     </p:spTree>
     <p:extLst>
       <p:ext uri="{BB962C8B-B14F-4D97-AF65-F5344CB8AC3E}">
-        <p14:creationId xmlns:p14="http://schemas.microsoft.com/office/powerpoint/2010/main" val="953369944"/>
+        <p14:creationId xmlns:p14="http://schemas.microsoft.com/office/powerpoint/2010/main" val="2877426691"/>
       </p:ext>
     </p:extLst>
   </p:cSld>
@@ -18809,6 +18665,41 @@
           <a:chExt cx="0" cy="0"/>
         </a:xfrm>
       </p:grpSpPr>
+      <p:pic>
+        <p:nvPicPr>
+          <p:cNvPr id="7" name="Picture 6">
+            <a:extLst>
+              <a:ext uri="{FF2B5EF4-FFF2-40B4-BE49-F238E27FC236}">
+                <a16:creationId xmlns:a16="http://schemas.microsoft.com/office/drawing/2014/main" id="{2A75CC74-F6B0-4379-9909-2DCCFB06535C}"/>
+              </a:ext>
+            </a:extLst>
+          </p:cNvPr>
+          <p:cNvPicPr>
+            <a:picLocks noChangeAspect="1"/>
+          </p:cNvPicPr>
+          <p:nvPr/>
+        </p:nvPicPr>
+        <p:blipFill>
+          <a:blip r:embed="rId2"/>
+          <a:stretch>
+            <a:fillRect/>
+          </a:stretch>
+        </p:blipFill>
+        <p:spPr>
+          <a:xfrm>
+            <a:off x="1514116" y="1277644"/>
+            <a:ext cx="6115767" cy="5261269"/>
+          </a:xfrm>
+          <a:prstGeom prst="rect">
+            <a:avLst/>
+          </a:prstGeom>
+          <a:ln>
+            <a:solidFill>
+              <a:schemeClr val="tx1"/>
+            </a:solidFill>
+          </a:ln>
+        </p:spPr>
+      </p:pic>
       <p:sp>
         <p:nvSpPr>
           <p:cNvPr id="2" name="Title 1"/>
@@ -18872,89 +18763,6 @@
       </p:sp>
       <p:sp>
         <p:nvSpPr>
-          <p:cNvPr id="21" name="Speech Bubble: Rectangle with Corners Rounded 20">
-            <a:extLst>
-              <a:ext uri="{FF2B5EF4-FFF2-40B4-BE49-F238E27FC236}">
-                <a16:creationId xmlns:a16="http://schemas.microsoft.com/office/drawing/2014/main" id="{FB70542E-CE07-4024-91C9-32200E403BE1}"/>
-              </a:ext>
-            </a:extLst>
-          </p:cNvPr>
-          <p:cNvSpPr/>
-          <p:nvPr/>
-        </p:nvSpPr>
-        <p:spPr>
-          <a:xfrm>
-            <a:off x="2083633" y="2572036"/>
-            <a:ext cx="1611442" cy="575898"/>
-          </a:xfrm>
-          <a:prstGeom prst="wedgeRoundRectCallout">
-            <a:avLst>
-              <a:gd name="adj1" fmla="val 116841"/>
-              <a:gd name="adj2" fmla="val -126212"/>
-              <a:gd name="adj3" fmla="val 16667"/>
-            </a:avLst>
-          </a:prstGeom>
-        </p:spPr>
-        <p:style>
-          <a:lnRef idx="2">
-            <a:schemeClr val="accent1">
-              <a:shade val="50000"/>
-            </a:schemeClr>
-          </a:lnRef>
-          <a:fillRef idx="1">
-            <a:schemeClr val="accent1"/>
-          </a:fillRef>
-          <a:effectRef idx="0">
-            <a:schemeClr val="accent1"/>
-          </a:effectRef>
-          <a:fontRef idx="minor">
-            <a:schemeClr val="lt1"/>
-          </a:fontRef>
-        </p:style>
-        <p:txBody>
-          <a:bodyPr rtlCol="0" anchor="ctr"/>
-          <a:lstStyle/>
-          <a:p>
-            <a:pPr algn="ctr"/>
-            <a:r>
-              <a:rPr lang="en-US" dirty="0"/>
-              <a:t>Click the "Run" button </a:t>
-            </a:r>
-          </a:p>
-        </p:txBody>
-      </p:sp>
-      <p:pic>
-        <p:nvPicPr>
-          <p:cNvPr id="3" name="Picture 2">
-            <a:extLst>
-              <a:ext uri="{FF2B5EF4-FFF2-40B4-BE49-F238E27FC236}">
-                <a16:creationId xmlns:a16="http://schemas.microsoft.com/office/drawing/2014/main" id="{4490DC95-9A99-41E5-8A0E-B374F7BB50F2}"/>
-              </a:ext>
-            </a:extLst>
-          </p:cNvPr>
-          <p:cNvPicPr>
-            <a:picLocks noChangeAspect="1"/>
-          </p:cNvPicPr>
-          <p:nvPr/>
-        </p:nvPicPr>
-        <p:blipFill>
-          <a:blip r:embed="rId2"/>
-          <a:stretch>
-            <a:fillRect/>
-          </a:stretch>
-        </p:blipFill>
-        <p:spPr>
-          <a:xfrm>
-            <a:off x="1235612" y="1315571"/>
-            <a:ext cx="6672775" cy="5325071"/>
-          </a:xfrm>
-          <a:prstGeom prst="rect">
-            <a:avLst/>
-          </a:prstGeom>
-        </p:spPr>
-      </p:pic>
-      <p:sp>
-        <p:nvSpPr>
           <p:cNvPr id="5" name="Rectangle 4">
             <a:extLst>
               <a:ext uri="{FF2B5EF4-FFF2-40B4-BE49-F238E27FC236}">
@@ -18967,7 +18775,7 @@
         </p:nvSpPr>
         <p:spPr>
           <a:xfrm>
-            <a:off x="1420249" y="4886793"/>
+            <a:off x="1757528" y="4939258"/>
             <a:ext cx="689548" cy="202368"/>
           </a:xfrm>
           <a:prstGeom prst="rect">
@@ -19019,7 +18827,7 @@
         </p:nvSpPr>
         <p:spPr>
           <a:xfrm>
-            <a:off x="2227289" y="3147934"/>
+            <a:off x="2564568" y="3200399"/>
             <a:ext cx="2725712" cy="1347859"/>
           </a:xfrm>
           <a:prstGeom prst="wedgeRoundRectCallout">
@@ -19061,7 +18869,7 @@
     </p:spTree>
     <p:extLst>
       <p:ext uri="{BB962C8B-B14F-4D97-AF65-F5344CB8AC3E}">
-        <p14:creationId xmlns:p14="http://schemas.microsoft.com/office/powerpoint/2010/main" val="217391447"/>
+        <p14:creationId xmlns:p14="http://schemas.microsoft.com/office/powerpoint/2010/main" val="2551500547"/>
       </p:ext>
     </p:extLst>
   </p:cSld>
@@ -24784,10 +24592,10 @@
       </p:grpSpPr>
       <p:pic>
         <p:nvPicPr>
-          <p:cNvPr id="23" name="Picture 22">
+          <p:cNvPr id="5" name="Picture 4">
             <a:extLst>
               <a:ext uri="{FF2B5EF4-FFF2-40B4-BE49-F238E27FC236}">
-                <a16:creationId xmlns:a16="http://schemas.microsoft.com/office/drawing/2014/main" id="{D7F1BCC1-821D-4BC3-8E46-9D20CBE6FAE7}"/>
+                <a16:creationId xmlns:a16="http://schemas.microsoft.com/office/drawing/2014/main" id="{E55120FB-2BE9-4B39-8E4D-505BCBF732F4}"/>
               </a:ext>
             </a:extLst>
           </p:cNvPr>
@@ -24804,8 +24612,8 @@
         </p:blipFill>
         <p:spPr>
           <a:xfrm>
-            <a:off x="840945" y="1468581"/>
-            <a:ext cx="7462111" cy="4887770"/>
+            <a:off x="860556" y="1507735"/>
+            <a:ext cx="7442499" cy="4752337"/>
           </a:xfrm>
           <a:prstGeom prst="rect">
             <a:avLst/>
@@ -24892,13 +24700,13 @@
         </p:nvSpPr>
         <p:spPr>
           <a:xfrm>
-            <a:off x="2083633" y="2572036"/>
+            <a:off x="2375941" y="3501426"/>
             <a:ext cx="1611442" cy="575898"/>
           </a:xfrm>
           <a:prstGeom prst="wedgeRoundRectCallout">
             <a:avLst>
-              <a:gd name="adj1" fmla="val 116841"/>
-              <a:gd name="adj2" fmla="val -126212"/>
+              <a:gd name="adj1" fmla="val 106608"/>
+              <a:gd name="adj2" fmla="val -278483"/>
               <a:gd name="adj3" fmla="val 16667"/>
             </a:avLst>
           </a:prstGeom>
@@ -24945,13 +24753,13 @@
         </p:nvSpPr>
         <p:spPr>
           <a:xfrm>
-            <a:off x="1793823" y="4813521"/>
+            <a:off x="197370" y="4062334"/>
             <a:ext cx="1901252" cy="575898"/>
           </a:xfrm>
           <a:prstGeom prst="wedgeRoundRectCallout">
             <a:avLst>
-              <a:gd name="adj1" fmla="val -51654"/>
-              <a:gd name="adj2" fmla="val -128815"/>
+              <a:gd name="adj1" fmla="val 37045"/>
+              <a:gd name="adj2" fmla="val -230329"/>
               <a:gd name="adj3" fmla="val 16667"/>
             </a:avLst>
           </a:prstGeom>

</xml_diff>

<commit_message>
Improve Chromebook install instructions
</commit_message>
<xml_diff>
--- a/slides/Installing the Courseware.pptx
+++ b/slides/Installing the Courseware.pptx
@@ -5,10 +5,10 @@
     <p:sldMasterId id="2147483660" r:id="rId1"/>
   </p:sldMasterIdLst>
   <p:notesMasterIdLst>
-    <p:notesMasterId r:id="rId44"/>
+    <p:notesMasterId r:id="rId45"/>
   </p:notesMasterIdLst>
   <p:handoutMasterIdLst>
-    <p:handoutMasterId r:id="rId45"/>
+    <p:handoutMasterId r:id="rId46"/>
   </p:handoutMasterIdLst>
   <p:sldIdLst>
     <p:sldId id="1143" r:id="rId2"/>
@@ -36,23 +36,24 @@
     <p:sldId id="1104" r:id="rId24"/>
     <p:sldId id="1133" r:id="rId25"/>
     <p:sldId id="1135" r:id="rId26"/>
-    <p:sldId id="1105" r:id="rId27"/>
-    <p:sldId id="1107" r:id="rId28"/>
-    <p:sldId id="1118" r:id="rId29"/>
-    <p:sldId id="1145" r:id="rId30"/>
-    <p:sldId id="1148" r:id="rId31"/>
-    <p:sldId id="1098" r:id="rId32"/>
-    <p:sldId id="1137" r:id="rId33"/>
-    <p:sldId id="1110" r:id="rId34"/>
-    <p:sldId id="1111" r:id="rId35"/>
-    <p:sldId id="1112" r:id="rId36"/>
-    <p:sldId id="1121" r:id="rId37"/>
-    <p:sldId id="1146" r:id="rId38"/>
-    <p:sldId id="1149" r:id="rId39"/>
-    <p:sldId id="1141" r:id="rId40"/>
-    <p:sldId id="933" r:id="rId41"/>
-    <p:sldId id="1125" r:id="rId42"/>
-    <p:sldId id="1142" r:id="rId43"/>
+    <p:sldId id="1150" r:id="rId27"/>
+    <p:sldId id="1105" r:id="rId28"/>
+    <p:sldId id="1107" r:id="rId29"/>
+    <p:sldId id="1151" r:id="rId30"/>
+    <p:sldId id="1145" r:id="rId31"/>
+    <p:sldId id="1148" r:id="rId32"/>
+    <p:sldId id="1098" r:id="rId33"/>
+    <p:sldId id="1137" r:id="rId34"/>
+    <p:sldId id="1110" r:id="rId35"/>
+    <p:sldId id="1111" r:id="rId36"/>
+    <p:sldId id="1112" r:id="rId37"/>
+    <p:sldId id="1121" r:id="rId38"/>
+    <p:sldId id="1146" r:id="rId39"/>
+    <p:sldId id="1149" r:id="rId40"/>
+    <p:sldId id="1141" r:id="rId41"/>
+    <p:sldId id="933" r:id="rId42"/>
+    <p:sldId id="1125" r:id="rId43"/>
+    <p:sldId id="1142" r:id="rId44"/>
   </p:sldIdLst>
   <p:sldSz cx="9144000" cy="6858000" type="screen4x3"/>
   <p:notesSz cx="6858000" cy="9313863"/>
@@ -11001,26 +11002,21 @@
             </a:r>
             <a:r>
               <a:rPr lang="en-US" sz="2000" dirty="0"/>
-              <a:t>– </a:t>
-            </a:r>
-            <a:r>
-              <a:rPr lang="en-US" sz="2000" dirty="0">
-                <a:hlinkClick r:id="rId2"/>
-              </a:rPr>
-              <a:t>https://git-scm.com/book/en/v2/Getting-Started-Installing-Git</a:t>
-            </a:r>
-            <a:r>
-              <a:rPr lang="en-US" sz="2000" dirty="0"/>
-              <a:t> (I recommend using '</a:t>
-            </a:r>
-            <a:r>
-              <a:rPr lang="en-US" sz="2000" dirty="0" err="1"/>
+              <a:t>– Enter this command: </a:t>
+            </a:r>
+            <a:r>
+              <a:rPr lang="en-US" sz="1800" b="1" dirty="0" err="1">
+                <a:latin typeface="Consolas" panose="020B0609020204030204" pitchFamily="49" charset="0"/>
+              </a:rPr>
               <a:t>sudo</a:t>
             </a:r>
             <a:r>
-              <a:rPr lang="en-US" sz="2000" dirty="0"/>
-              <a:t> apt install git-all')</a:t>
-            </a:r>
+              <a:rPr lang="en-US" sz="1800" b="1" dirty="0">
+                <a:latin typeface="Consolas" panose="020B0609020204030204" pitchFamily="49" charset="0"/>
+              </a:rPr>
+              <a:t> apt install –y git-all</a:t>
+            </a:r>
+            <a:endParaRPr lang="en-US" sz="2000" dirty="0"/>
           </a:p>
           <a:p>
             <a:pPr marL="457200" indent="-457200">
@@ -11046,17 +11042,15 @@
             </a:r>
             <a:r>
               <a:rPr lang="en-US" sz="2000" dirty="0"/>
-              <a:t> for Linux – please read this first: </a:t>
-            </a:r>
-            <a:r>
-              <a:rPr lang="en-US" sz="2000" dirty="0">
-                <a:hlinkClick r:id="rId3"/>
-              </a:rPr>
-              <a:t>https://docs.conda.io/projects/conda/en/latest/user-guide/install/linux.html</a:t>
+              <a:t> – Using the built-in Chrome web browser (which runs outside of the Linux Terminal) go to </a:t>
+            </a:r>
+            <a:r>
+              <a:rPr lang="en-US" sz="2000" b="1" dirty="0"/>
+              <a:t>one</a:t>
             </a:r>
             <a:r>
               <a:rPr lang="en-US" sz="2000" dirty="0"/>
-              <a:t> - then do this:</a:t>
+              <a:t> of these links:</a:t>
             </a:r>
             <a:endParaRPr lang="en-US" sz="2000" b="1" dirty="0"/>
           </a:p>
@@ -11088,19 +11082,11 @@
             </a:r>
             <a:r>
               <a:rPr lang="en-US" sz="1600" dirty="0"/>
-              <a:t> Chromebook: download and run the script </a:t>
-            </a:r>
-            <a:r>
-              <a:rPr lang="en-US" sz="1600" b="1" dirty="0"/>
-              <a:t>Miniconda3 Linux 64-bit</a:t>
-            </a:r>
-            <a:r>
-              <a:rPr lang="en-US" sz="1600" dirty="0"/>
-              <a:t> </a:t>
+              <a:t> Chromebook, go to this link: </a:t>
             </a:r>
             <a:r>
               <a:rPr lang="en-US" sz="1600" dirty="0">
-                <a:hlinkClick r:id="rId4"/>
+                <a:hlinkClick r:id="rId2"/>
               </a:rPr>
               <a:t>https://repo.anaconda.com/miniconda/Miniconda3-latest-Linux-x86_64.sh</a:t>
             </a:r>
@@ -11134,19 +11120,11 @@
             </a:r>
             <a:r>
               <a:rPr lang="en-US" sz="1600" dirty="0"/>
-              <a:t> Chromebook: download and run the script </a:t>
-            </a:r>
-            <a:r>
-              <a:rPr lang="en-US" sz="1600" b="1" dirty="0"/>
-              <a:t>Miniconda3 Linux-aarch64 64-bit</a:t>
-            </a:r>
-            <a:r>
-              <a:rPr lang="en-US" sz="1600" dirty="0"/>
-              <a:t> </a:t>
+              <a:t> Chromebook, go to this link: </a:t>
             </a:r>
             <a:r>
               <a:rPr lang="en-US" sz="1600" dirty="0">
-                <a:hlinkClick r:id="rId5"/>
+                <a:hlinkClick r:id="rId3"/>
               </a:rPr>
               <a:t>https://repo.anaconda.com/miniconda/Miniconda3-latest-Linux-aarch64.sh</a:t>
             </a:r>
@@ -12580,8 +12558,8 @@
         </p:nvSpPr>
         <p:spPr>
           <a:xfrm>
-            <a:off x="1337872" y="1398216"/>
-            <a:ext cx="6468256" cy="646331"/>
+            <a:off x="839449" y="1398216"/>
+            <a:ext cx="7675901" cy="646331"/>
           </a:xfrm>
           <a:prstGeom prst="rect">
             <a:avLst/>
@@ -12601,50 +12579,23 @@
                   <a:srgbClr val="FF0000"/>
                 </a:solidFill>
               </a:rPr>
-              <a:t>To run the Miniconda install script that you downloaded,</a:t>
-            </a:r>
-          </a:p>
-          <a:p>
-            <a:pPr algn="ctr"/>
+              <a:t>To run the Miniconda install script that you downloaded, in the Terminal window, type these </a:t>
+            </a:r>
+            <a:r>
+              <a:rPr lang="en-US" sz="1800" b="1" u="sng" dirty="0">
+                <a:solidFill>
+                  <a:srgbClr val="FF0000"/>
+                </a:solidFill>
+              </a:rPr>
+              <a:t>two</a:t>
+            </a:r>
             <a:r>
               <a:rPr lang="en-US" sz="1800" b="1" dirty="0">
                 <a:solidFill>
                   <a:srgbClr val="FF0000"/>
                 </a:solidFill>
               </a:rPr>
-              <a:t>open a </a:t>
-            </a:r>
-            <a:r>
-              <a:rPr lang="en-US" sz="1800" b="1" u="sng" dirty="0">
-                <a:solidFill>
-                  <a:srgbClr val="FF0000"/>
-                </a:solidFill>
-              </a:rPr>
-              <a:t>new</a:t>
-            </a:r>
-            <a:r>
-              <a:rPr lang="en-US" sz="1800" b="1" dirty="0">
-                <a:solidFill>
-                  <a:srgbClr val="FF0000"/>
-                </a:solidFill>
-              </a:rPr>
-              <a:t> Terminal session, and type these </a:t>
-            </a:r>
-            <a:r>
-              <a:rPr lang="en-US" sz="1800" b="1" u="sng" dirty="0">
-                <a:solidFill>
-                  <a:srgbClr val="FF0000"/>
-                </a:solidFill>
-              </a:rPr>
-              <a:t>two</a:t>
-            </a:r>
-            <a:r>
-              <a:rPr lang="en-US" sz="1800" b="1" dirty="0">
-                <a:solidFill>
-                  <a:srgbClr val="FF0000"/>
-                </a:solidFill>
-              </a:rPr>
-              <a:t> commands</a:t>
+              <a:t> commands based upon your CPU type:</a:t>
             </a:r>
             <a:endParaRPr lang="en-US" b="1" dirty="0">
               <a:solidFill>
@@ -12863,7 +12814,7 @@
               <a:rPr lang="en-US" sz="1800" dirty="0">
                 <a:latin typeface="Consolas" panose="020B0609020204030204" pitchFamily="49" charset="0"/>
               </a:rPr>
-              <a:t>cd $HOME/Downloads</a:t>
+              <a:t>cd $HOME</a:t>
             </a:r>
           </a:p>
           <a:p>
@@ -12884,8 +12835,13 @@
               <a:rPr lang="en-US" sz="1800" dirty="0">
                 <a:latin typeface="Consolas" panose="020B0609020204030204" pitchFamily="49" charset="0"/>
               </a:rPr>
-              <a:t>bash Miniconda3-latest-Linux-x86_64.sh (if on Intel CPU)</a:t>
-            </a:r>
+              <a:t>bash Miniconda3-latest-Linux-x86_64.sh</a:t>
+            </a:r>
+            <a:endParaRPr lang="en-US" sz="1800" i="1" dirty="0">
+              <a:solidFill>
+                <a:srgbClr val="0070C0"/>
+              </a:solidFill>
+            </a:endParaRPr>
           </a:p>
           <a:p>
             <a:pPr marL="457200" lvl="1" indent="0">
@@ -12929,7 +12885,7 @@
               <a:rPr lang="en-US" sz="1800" dirty="0">
                 <a:latin typeface="Consolas" panose="020B0609020204030204" pitchFamily="49" charset="0"/>
               </a:rPr>
-              <a:t>bash Miniconda3-latest-Linux-aarch64.sh (if on M1 CPU)</a:t>
+              <a:t>bash Miniconda3-latest-Linux-aarch64.sh</a:t>
             </a:r>
           </a:p>
         </p:txBody>
@@ -12948,6 +12904,442 @@
 </file>
 
 <file path=ppt/slides/slide26.xml><?xml version="1.0" encoding="utf-8"?>
+<p:sld xmlns:a="http://schemas.openxmlformats.org/drawingml/2006/main" xmlns:r="http://schemas.openxmlformats.org/officeDocument/2006/relationships" xmlns:p="http://schemas.openxmlformats.org/presentationml/2006/main">
+  <p:cSld>
+    <p:spTree>
+      <p:nvGrpSpPr>
+        <p:cNvPr id="1" name=""/>
+        <p:cNvGrpSpPr/>
+        <p:nvPr/>
+      </p:nvGrpSpPr>
+      <p:grpSpPr>
+        <a:xfrm>
+          <a:off x="0" y="0"/>
+          <a:ext cx="0" cy="0"/>
+          <a:chOff x="0" y="0"/>
+          <a:chExt cx="0" cy="0"/>
+        </a:xfrm>
+      </p:grpSpPr>
+      <p:pic>
+        <p:nvPicPr>
+          <p:cNvPr id="5" name="Picture 4">
+            <a:extLst>
+              <a:ext uri="{FF2B5EF4-FFF2-40B4-BE49-F238E27FC236}">
+                <a16:creationId xmlns:a16="http://schemas.microsoft.com/office/drawing/2014/main" id="{B7992590-7EFF-4336-9E0E-9534FCAC4FBD}"/>
+              </a:ext>
+            </a:extLst>
+          </p:cNvPr>
+          <p:cNvPicPr>
+            <a:picLocks noChangeAspect="1"/>
+          </p:cNvPicPr>
+          <p:nvPr/>
+        </p:nvPicPr>
+        <p:blipFill>
+          <a:blip r:embed="rId2"/>
+          <a:stretch>
+            <a:fillRect/>
+          </a:stretch>
+        </p:blipFill>
+        <p:spPr>
+          <a:xfrm>
+            <a:off x="1571611" y="2167008"/>
+            <a:ext cx="6063521" cy="4483507"/>
+          </a:xfrm>
+          <a:prstGeom prst="rect">
+            <a:avLst/>
+          </a:prstGeom>
+        </p:spPr>
+      </p:pic>
+      <p:sp>
+        <p:nvSpPr>
+          <p:cNvPr id="2" name="Title 1"/>
+          <p:cNvSpPr>
+            <a:spLocks noGrp="1"/>
+          </p:cNvSpPr>
+          <p:nvPr>
+            <p:ph type="title"/>
+          </p:nvPr>
+        </p:nvSpPr>
+        <p:spPr>
+          <a:xfrm>
+            <a:off x="628650" y="365126"/>
+            <a:ext cx="7886700" cy="1103455"/>
+          </a:xfrm>
+        </p:spPr>
+        <p:txBody>
+          <a:bodyPr>
+            <a:noAutofit/>
+          </a:bodyPr>
+          <a:lstStyle/>
+          <a:p>
+            <a:pPr algn="ctr"/>
+            <a:r>
+              <a:rPr lang="en-US" sz="3200" dirty="0">
+                <a:latin typeface="+mn-lt"/>
+              </a:rPr>
+              <a:t>Google Chromebook Linux – </a:t>
+            </a:r>
+            <a:r>
+              <a:rPr lang="en-US" sz="3200" b="1" dirty="0">
+                <a:latin typeface="+mn-lt"/>
+              </a:rPr>
+              <a:t>Phase 1</a:t>
+            </a:r>
+          </a:p>
+        </p:txBody>
+      </p:sp>
+      <p:sp>
+        <p:nvSpPr>
+          <p:cNvPr id="4" name="Slide Number Placeholder 3"/>
+          <p:cNvSpPr>
+            <a:spLocks noGrp="1"/>
+          </p:cNvSpPr>
+          <p:nvPr>
+            <p:ph type="sldNum" sz="quarter" idx="12"/>
+          </p:nvPr>
+        </p:nvSpPr>
+        <p:spPr/>
+        <p:txBody>
+          <a:bodyPr/>
+          <a:lstStyle/>
+          <a:p>
+            <a:fld id="{650AD656-6FF9-465D-B7B0-1CD0DD39CD23}" type="slidenum">
+              <a:rPr lang="en-US" smtClean="0"/>
+              <a:t>26</a:t>
+            </a:fld>
+            <a:endParaRPr lang="en-US"/>
+          </a:p>
+        </p:txBody>
+      </p:sp>
+      <p:grpSp>
+        <p:nvGrpSpPr>
+          <p:cNvPr id="17" name="Group 16">
+            <a:extLst>
+              <a:ext uri="{FF2B5EF4-FFF2-40B4-BE49-F238E27FC236}">
+                <a16:creationId xmlns:a16="http://schemas.microsoft.com/office/drawing/2014/main" id="{0BA8990C-8D06-4B4B-B540-76D7B4817B52}"/>
+              </a:ext>
+            </a:extLst>
+          </p:cNvPr>
+          <p:cNvGrpSpPr/>
+          <p:nvPr/>
+        </p:nvGrpSpPr>
+        <p:grpSpPr>
+          <a:xfrm>
+            <a:off x="2622858" y="6288432"/>
+            <a:ext cx="1076632" cy="369332"/>
+            <a:chOff x="4968362" y="2079211"/>
+            <a:chExt cx="1076632" cy="369332"/>
+          </a:xfrm>
+        </p:grpSpPr>
+        <p:cxnSp>
+          <p:nvCxnSpPr>
+            <p:cNvPr id="19" name="Straight Arrow Connector 18">
+              <a:extLst>
+                <a:ext uri="{FF2B5EF4-FFF2-40B4-BE49-F238E27FC236}">
+                  <a16:creationId xmlns:a16="http://schemas.microsoft.com/office/drawing/2014/main" id="{7A244521-213D-4FD1-9F2D-96041FB745B3}"/>
+                </a:ext>
+              </a:extLst>
+            </p:cNvPr>
+            <p:cNvCxnSpPr>
+              <a:cxnSpLocks/>
+            </p:cNvCxnSpPr>
+            <p:nvPr/>
+          </p:nvCxnSpPr>
+          <p:spPr>
+            <a:xfrm flipH="1">
+              <a:off x="4968362" y="2263877"/>
+              <a:ext cx="693174" cy="0"/>
+            </a:xfrm>
+            <a:prstGeom prst="straightConnector1">
+              <a:avLst/>
+            </a:prstGeom>
+            <a:ln w="38100">
+              <a:solidFill>
+                <a:srgbClr val="FF0000"/>
+              </a:solidFill>
+              <a:tailEnd type="triangle"/>
+            </a:ln>
+          </p:spPr>
+          <p:style>
+            <a:lnRef idx="1">
+              <a:schemeClr val="accent1"/>
+            </a:lnRef>
+            <a:fillRef idx="0">
+              <a:schemeClr val="accent1"/>
+            </a:fillRef>
+            <a:effectRef idx="0">
+              <a:schemeClr val="accent1"/>
+            </a:effectRef>
+            <a:fontRef idx="minor">
+              <a:schemeClr val="tx1"/>
+            </a:fontRef>
+          </p:style>
+        </p:cxnSp>
+        <p:sp>
+          <p:nvSpPr>
+            <p:cNvPr id="20" name="TextBox 19">
+              <a:extLst>
+                <a:ext uri="{FF2B5EF4-FFF2-40B4-BE49-F238E27FC236}">
+                  <a16:creationId xmlns:a16="http://schemas.microsoft.com/office/drawing/2014/main" id="{E5B66372-C288-4D9D-B01F-78B8E14A4E2C}"/>
+                </a:ext>
+              </a:extLst>
+            </p:cNvPr>
+            <p:cNvSpPr txBox="1"/>
+            <p:nvPr/>
+          </p:nvSpPr>
+          <p:spPr>
+            <a:xfrm>
+              <a:off x="5661536" y="2079211"/>
+              <a:ext cx="383458" cy="369332"/>
+            </a:xfrm>
+            <a:prstGeom prst="rect">
+              <a:avLst/>
+            </a:prstGeom>
+            <a:noFill/>
+          </p:spPr>
+          <p:txBody>
+            <a:bodyPr wrap="square" rtlCol="0">
+              <a:spAutoFit/>
+            </a:bodyPr>
+            <a:lstStyle/>
+            <a:p>
+              <a:r>
+                <a:rPr lang="en-US" dirty="0">
+                  <a:ln>
+                    <a:solidFill>
+                      <a:srgbClr val="FF0000"/>
+                    </a:solidFill>
+                  </a:ln>
+                  <a:solidFill>
+                    <a:srgbClr val="FF0000"/>
+                  </a:solidFill>
+                  <a:sym typeface="Wingdings" panose="05000000000000000000" pitchFamily="2" charset="2"/>
+                </a:rPr>
+                <a:t></a:t>
+              </a:r>
+              <a:endParaRPr lang="en-US" dirty="0">
+                <a:ln>
+                  <a:solidFill>
+                    <a:srgbClr val="FF0000"/>
+                  </a:solidFill>
+                </a:ln>
+                <a:solidFill>
+                  <a:srgbClr val="FF0000"/>
+                </a:solidFill>
+              </a:endParaRPr>
+            </a:p>
+          </p:txBody>
+        </p:sp>
+      </p:grpSp>
+      <p:sp>
+        <p:nvSpPr>
+          <p:cNvPr id="14" name="TextBox 13">
+            <a:extLst>
+              <a:ext uri="{FF2B5EF4-FFF2-40B4-BE49-F238E27FC236}">
+                <a16:creationId xmlns:a16="http://schemas.microsoft.com/office/drawing/2014/main" id="{00524E8A-2932-4D89-8BDC-F9D587CC26E6}"/>
+              </a:ext>
+            </a:extLst>
+          </p:cNvPr>
+          <p:cNvSpPr txBox="1"/>
+          <p:nvPr/>
+        </p:nvSpPr>
+        <p:spPr>
+          <a:xfrm>
+            <a:off x="839449" y="1398216"/>
+            <a:ext cx="7675901" cy="646331"/>
+          </a:xfrm>
+          <a:prstGeom prst="rect">
+            <a:avLst/>
+          </a:prstGeom>
+          <a:noFill/>
+        </p:spPr>
+        <p:txBody>
+          <a:bodyPr wrap="square" rtlCol="0">
+            <a:spAutoFit/>
+          </a:bodyPr>
+          <a:lstStyle/>
+          <a:p>
+            <a:pPr algn="ctr"/>
+            <a:r>
+              <a:rPr lang="en-US" sz="1800" b="1" dirty="0">
+                <a:solidFill>
+                  <a:srgbClr val="FF0000"/>
+                </a:solidFill>
+              </a:rPr>
+              <a:t>Accept the terms of the license, and type </a:t>
+            </a:r>
+            <a:r>
+              <a:rPr lang="en-US" sz="1800" b="1" dirty="0"/>
+              <a:t>yes</a:t>
+            </a:r>
+            <a:r>
+              <a:rPr lang="en-US" sz="1800" b="1" dirty="0">
+                <a:solidFill>
+                  <a:srgbClr val="FF0000"/>
+                </a:solidFill>
+              </a:rPr>
+              <a:t> at the final question.</a:t>
+            </a:r>
+          </a:p>
+          <a:p>
+            <a:pPr algn="ctr"/>
+            <a:r>
+              <a:rPr lang="en-US" b="1" dirty="0">
+                <a:solidFill>
+                  <a:srgbClr val="FF0000"/>
+                </a:solidFill>
+              </a:rPr>
+              <a:t>When the installer finishes, </a:t>
+            </a:r>
+            <a:r>
+              <a:rPr lang="en-US" b="1" dirty="0"/>
+              <a:t>close</a:t>
+            </a:r>
+            <a:r>
+              <a:rPr lang="en-US" b="1" dirty="0">
+                <a:solidFill>
+                  <a:srgbClr val="FF0000"/>
+                </a:solidFill>
+              </a:rPr>
+              <a:t> this Terminal Session:</a:t>
+            </a:r>
+          </a:p>
+        </p:txBody>
+      </p:sp>
+      <p:grpSp>
+        <p:nvGrpSpPr>
+          <p:cNvPr id="16" name="Group 15">
+            <a:extLst>
+              <a:ext uri="{FF2B5EF4-FFF2-40B4-BE49-F238E27FC236}">
+                <a16:creationId xmlns:a16="http://schemas.microsoft.com/office/drawing/2014/main" id="{9643DA34-AFA9-44C3-86CB-B3805792A43F}"/>
+              </a:ext>
+            </a:extLst>
+          </p:cNvPr>
+          <p:cNvGrpSpPr/>
+          <p:nvPr/>
+        </p:nvGrpSpPr>
+        <p:grpSpPr>
+          <a:xfrm>
+            <a:off x="7572389" y="2142697"/>
+            <a:ext cx="1076632" cy="369332"/>
+            <a:chOff x="4704120" y="2356972"/>
+            <a:chExt cx="1076632" cy="369332"/>
+          </a:xfrm>
+        </p:grpSpPr>
+        <p:cxnSp>
+          <p:nvCxnSpPr>
+            <p:cNvPr id="18" name="Straight Arrow Connector 17">
+              <a:extLst>
+                <a:ext uri="{FF2B5EF4-FFF2-40B4-BE49-F238E27FC236}">
+                  <a16:creationId xmlns:a16="http://schemas.microsoft.com/office/drawing/2014/main" id="{7367773B-A6EA-491B-8066-D3272FBFD6C5}"/>
+                </a:ext>
+              </a:extLst>
+            </p:cNvPr>
+            <p:cNvCxnSpPr>
+              <a:cxnSpLocks/>
+            </p:cNvCxnSpPr>
+            <p:nvPr/>
+          </p:nvCxnSpPr>
+          <p:spPr>
+            <a:xfrm flipH="1">
+              <a:off x="4704120" y="2541638"/>
+              <a:ext cx="693174" cy="0"/>
+            </a:xfrm>
+            <a:prstGeom prst="straightConnector1">
+              <a:avLst/>
+            </a:prstGeom>
+            <a:ln w="38100">
+              <a:solidFill>
+                <a:srgbClr val="FF0000"/>
+              </a:solidFill>
+              <a:tailEnd type="triangle"/>
+            </a:ln>
+          </p:spPr>
+          <p:style>
+            <a:lnRef idx="1">
+              <a:schemeClr val="accent1"/>
+            </a:lnRef>
+            <a:fillRef idx="0">
+              <a:schemeClr val="accent1"/>
+            </a:fillRef>
+            <a:effectRef idx="0">
+              <a:schemeClr val="accent1"/>
+            </a:effectRef>
+            <a:fontRef idx="minor">
+              <a:schemeClr val="tx1"/>
+            </a:fontRef>
+          </p:style>
+        </p:cxnSp>
+        <p:sp>
+          <p:nvSpPr>
+            <p:cNvPr id="21" name="TextBox 20">
+              <a:extLst>
+                <a:ext uri="{FF2B5EF4-FFF2-40B4-BE49-F238E27FC236}">
+                  <a16:creationId xmlns:a16="http://schemas.microsoft.com/office/drawing/2014/main" id="{63752929-960A-4375-B2D3-50DBD067747E}"/>
+                </a:ext>
+              </a:extLst>
+            </p:cNvPr>
+            <p:cNvSpPr txBox="1"/>
+            <p:nvPr/>
+          </p:nvSpPr>
+          <p:spPr>
+            <a:xfrm>
+              <a:off x="5397294" y="2356972"/>
+              <a:ext cx="383458" cy="369332"/>
+            </a:xfrm>
+            <a:prstGeom prst="rect">
+              <a:avLst/>
+            </a:prstGeom>
+            <a:noFill/>
+          </p:spPr>
+          <p:txBody>
+            <a:bodyPr wrap="square" rtlCol="0">
+              <a:spAutoFit/>
+            </a:bodyPr>
+            <a:lstStyle/>
+            <a:p>
+              <a:r>
+                <a:rPr lang="en-US" dirty="0">
+                  <a:ln>
+                    <a:solidFill>
+                      <a:srgbClr val="FF0000"/>
+                    </a:solidFill>
+                  </a:ln>
+                  <a:solidFill>
+                    <a:srgbClr val="FF0000"/>
+                  </a:solidFill>
+                  <a:sym typeface="Wingdings" panose="05000000000000000000" pitchFamily="2" charset="2"/>
+                </a:rPr>
+                <a:t></a:t>
+              </a:r>
+              <a:endParaRPr lang="en-US" dirty="0">
+                <a:ln>
+                  <a:solidFill>
+                    <a:srgbClr val="FF0000"/>
+                  </a:solidFill>
+                </a:ln>
+                <a:solidFill>
+                  <a:srgbClr val="FF0000"/>
+                </a:solidFill>
+              </a:endParaRPr>
+            </a:p>
+          </p:txBody>
+        </p:sp>
+      </p:grpSp>
+    </p:spTree>
+    <p:extLst>
+      <p:ext uri="{BB962C8B-B14F-4D97-AF65-F5344CB8AC3E}">
+        <p14:creationId xmlns:p14="http://schemas.microsoft.com/office/powerpoint/2010/main" val="46842425"/>
+      </p:ext>
+    </p:extLst>
+  </p:cSld>
+  <p:clrMapOvr>
+    <a:masterClrMapping/>
+  </p:clrMapOvr>
+</p:sld>
+</file>
+
+<file path=ppt/slides/slide27.xml><?xml version="1.0" encoding="utf-8"?>
 <p:sld xmlns:a="http://schemas.openxmlformats.org/drawingml/2006/main" xmlns:r="http://schemas.openxmlformats.org/officeDocument/2006/relationships" xmlns:p="http://schemas.openxmlformats.org/presentationml/2006/main">
   <p:cSld>
     <p:spTree>
@@ -13151,7 +13543,7 @@
           <a:p>
             <a:fld id="{650AD656-6FF9-465D-B7B0-1CD0DD39CD23}" type="slidenum">
               <a:rPr lang="en-US" smtClean="0"/>
-              <a:t>26</a:t>
+              <a:t>27</a:t>
             </a:fld>
             <a:endParaRPr lang="en-US"/>
           </a:p>
@@ -13172,7 +13564,7 @@
         <p:spPr>
           <a:xfrm>
             <a:off x="1337872" y="1398216"/>
-            <a:ext cx="6468256" cy="369332"/>
+            <a:ext cx="6468256" cy="923330"/>
           </a:xfrm>
           <a:prstGeom prst="rect">
             <a:avLst/>
@@ -13192,7 +13584,7 @@
                   <a:srgbClr val="FF0000"/>
                 </a:solidFill>
               </a:rPr>
-              <a:t>Start a Terminal session and execute these </a:t>
+              <a:t>Open a </a:t>
             </a:r>
             <a:r>
               <a:rPr lang="en-US" sz="1800" b="1" u="sng" dirty="0">
@@ -13200,7 +13592,7 @@
                   <a:srgbClr val="FF0000"/>
                 </a:solidFill>
               </a:rPr>
-              <a:t>four</a:t>
+              <a:t>new</a:t>
             </a:r>
             <a:r>
               <a:rPr lang="en-US" sz="1800" b="1" dirty="0">
@@ -13208,8 +13600,50 @@
                   <a:srgbClr val="FF0000"/>
                 </a:solidFill>
               </a:rPr>
-              <a:t> commands:</a:t>
-            </a:r>
+              <a:t> Terminal session and execute these </a:t>
+            </a:r>
+            <a:r>
+              <a:rPr lang="en-US" sz="1800" b="1" u="sng" dirty="0">
+                <a:solidFill>
+                  <a:srgbClr val="FF0000"/>
+                </a:solidFill>
+              </a:rPr>
+              <a:t>four</a:t>
+            </a:r>
+            <a:r>
+              <a:rPr lang="en-US" sz="1800" b="1" dirty="0">
+                <a:solidFill>
+                  <a:srgbClr val="FF0000"/>
+                </a:solidFill>
+              </a:rPr>
+              <a:t> commands.</a:t>
+            </a:r>
+          </a:p>
+          <a:p>
+            <a:pPr algn="ctr"/>
+            <a:r>
+              <a:rPr lang="en-US" b="1" dirty="0">
+                <a:solidFill>
+                  <a:srgbClr val="FF0000"/>
+                </a:solidFill>
+              </a:rPr>
+              <a:t>When the installer finishes, </a:t>
+            </a:r>
+            <a:r>
+              <a:rPr lang="en-US" b="1" dirty="0"/>
+              <a:t>close</a:t>
+            </a:r>
+            <a:r>
+              <a:rPr lang="en-US" b="1" dirty="0">
+                <a:solidFill>
+                  <a:srgbClr val="FF0000"/>
+                </a:solidFill>
+              </a:rPr>
+              <a:t> this Terminal Session</a:t>
+            </a:r>
+          </a:p>
+          <a:p>
+            <a:pPr algn="ctr"/>
             <a:endParaRPr lang="en-US" b="1" dirty="0">
               <a:solidFill>
                 <a:srgbClr val="FF0000"/>
@@ -13371,7 +13805,7 @@
 </p:sld>
 </file>
 
-<file path=ppt/slides/slide27.xml><?xml version="1.0" encoding="utf-8"?>
+<file path=ppt/slides/slide28.xml><?xml version="1.0" encoding="utf-8"?>
 <p:sld xmlns:a="http://schemas.openxmlformats.org/drawingml/2006/main" xmlns:r="http://schemas.openxmlformats.org/officeDocument/2006/relationships" xmlns:p="http://schemas.openxmlformats.org/presentationml/2006/main">
   <p:cSld>
     <p:spTree>
@@ -13574,7 +14008,7 @@
           <a:p>
             <a:fld id="{650AD656-6FF9-465D-B7B0-1CD0DD39CD23}" type="slidenum">
               <a:rPr lang="en-US" smtClean="0"/>
-              <a:t>27</a:t>
+              <a:t>28</a:t>
             </a:fld>
             <a:endParaRPr lang="en-US"/>
           </a:p>
@@ -13615,7 +14049,7 @@
                   <a:srgbClr val="FF0000"/>
                 </a:solidFill>
               </a:rPr>
-              <a:t>Start a </a:t>
+              <a:t>Open a </a:t>
             </a:r>
             <a:r>
               <a:rPr lang="en-US" sz="1800" b="1" u="sng" dirty="0">
@@ -13670,7 +14104,7 @@
 </p:sld>
 </file>
 
-<file path=ppt/slides/slide28.xml><?xml version="1.0" encoding="utf-8"?>
+<file path=ppt/slides/slide29.xml><?xml version="1.0" encoding="utf-8"?>
 <p:sld xmlns:a="http://schemas.openxmlformats.org/drawingml/2006/main" xmlns:r="http://schemas.openxmlformats.org/officeDocument/2006/relationships" xmlns:p="http://schemas.openxmlformats.org/presentationml/2006/main">
   <p:cSld>
     <p:spTree>
@@ -13689,10 +14123,10 @@
       </p:grpSpPr>
       <p:pic>
         <p:nvPicPr>
-          <p:cNvPr id="23" name="Picture 22">
+          <p:cNvPr id="5" name="Picture 4">
             <a:extLst>
               <a:ext uri="{FF2B5EF4-FFF2-40B4-BE49-F238E27FC236}">
-                <a16:creationId xmlns:a16="http://schemas.microsoft.com/office/drawing/2014/main" id="{D7F1BCC1-821D-4BC3-8E46-9D20CBE6FAE7}"/>
+                <a16:creationId xmlns:a16="http://schemas.microsoft.com/office/drawing/2014/main" id="{E55120FB-2BE9-4B39-8E4D-505BCBF732F4}"/>
               </a:ext>
             </a:extLst>
           </p:cNvPr>
@@ -13709,8 +14143,8 @@
         </p:blipFill>
         <p:spPr>
           <a:xfrm>
-            <a:off x="840945" y="1468581"/>
-            <a:ext cx="7462111" cy="4887770"/>
+            <a:off x="860556" y="1507735"/>
+            <a:ext cx="7442499" cy="4752337"/>
           </a:xfrm>
           <a:prstGeom prst="rect">
             <a:avLst/>
@@ -13777,7 +14211,7 @@
           <a:p>
             <a:fld id="{650AD656-6FF9-465D-B7B0-1CD0DD39CD23}" type="slidenum">
               <a:rPr lang="en-US" smtClean="0"/>
-              <a:t>28</a:t>
+              <a:t>29</a:t>
             </a:fld>
             <a:endParaRPr lang="en-US"/>
           </a:p>
@@ -13797,13 +14231,13 @@
         </p:nvSpPr>
         <p:spPr>
           <a:xfrm>
-            <a:off x="2083633" y="2572036"/>
+            <a:off x="2375941" y="3501426"/>
             <a:ext cx="1611442" cy="575898"/>
           </a:xfrm>
           <a:prstGeom prst="wedgeRoundRectCallout">
             <a:avLst>
-              <a:gd name="adj1" fmla="val 116841"/>
-              <a:gd name="adj2" fmla="val -126212"/>
+              <a:gd name="adj1" fmla="val 106608"/>
+              <a:gd name="adj2" fmla="val -278483"/>
               <a:gd name="adj3" fmla="val 16667"/>
             </a:avLst>
           </a:prstGeom>
@@ -13841,7 +14275,7 @@
           <p:cNvPr id="6" name="Speech Bubble: Rectangle with Corners Rounded 5">
             <a:extLst>
               <a:ext uri="{FF2B5EF4-FFF2-40B4-BE49-F238E27FC236}">
-                <a16:creationId xmlns:a16="http://schemas.microsoft.com/office/drawing/2014/main" id="{90CE37F1-817C-49AF-9890-03C13EAF639E}"/>
+                <a16:creationId xmlns:a16="http://schemas.microsoft.com/office/drawing/2014/main" id="{24429594-581A-4F96-86CE-B1A2FE5F3FA7}"/>
               </a:ext>
             </a:extLst>
           </p:cNvPr>
@@ -13850,13 +14284,13 @@
         </p:nvSpPr>
         <p:spPr>
           <a:xfrm>
-            <a:off x="1793823" y="4813521"/>
+            <a:off x="197370" y="4062334"/>
             <a:ext cx="1901252" cy="575898"/>
           </a:xfrm>
           <a:prstGeom prst="wedgeRoundRectCallout">
             <a:avLst>
-              <a:gd name="adj1" fmla="val -51654"/>
-              <a:gd name="adj2" fmla="val -128815"/>
+              <a:gd name="adj1" fmla="val 37045"/>
+              <a:gd name="adj2" fmla="val -230329"/>
               <a:gd name="adj3" fmla="val 16667"/>
             </a:avLst>
           </a:prstGeom>
@@ -13892,7 +14326,7 @@
     </p:spTree>
     <p:extLst>
       <p:ext uri="{BB962C8B-B14F-4D97-AF65-F5344CB8AC3E}">
-        <p14:creationId xmlns:p14="http://schemas.microsoft.com/office/powerpoint/2010/main" val="4163431308"/>
+        <p14:creationId xmlns:p14="http://schemas.microsoft.com/office/powerpoint/2010/main" val="1401651468"/>
       </p:ext>
     </p:extLst>
   </p:cSld>
@@ -14036,127 +14470,6 @@
 </p:sld>
 </file>
 
-<file path=ppt/slides/slide29.xml><?xml version="1.0" encoding="utf-8"?>
-<p:sld xmlns:a="http://schemas.openxmlformats.org/drawingml/2006/main" xmlns:r="http://schemas.openxmlformats.org/officeDocument/2006/relationships" xmlns:p="http://schemas.openxmlformats.org/presentationml/2006/main">
-  <p:cSld>
-    <p:spTree>
-      <p:nvGrpSpPr>
-        <p:cNvPr id="1" name=""/>
-        <p:cNvGrpSpPr/>
-        <p:nvPr/>
-      </p:nvGrpSpPr>
-      <p:grpSpPr>
-        <a:xfrm>
-          <a:off x="0" y="0"/>
-          <a:ext cx="0" cy="0"/>
-          <a:chOff x="0" y="0"/>
-          <a:chExt cx="0" cy="0"/>
-        </a:xfrm>
-      </p:grpSpPr>
-      <p:sp>
-        <p:nvSpPr>
-          <p:cNvPr id="2" name="Title 1"/>
-          <p:cNvSpPr>
-            <a:spLocks noGrp="1"/>
-          </p:cNvSpPr>
-          <p:nvPr>
-            <p:ph type="title"/>
-          </p:nvPr>
-        </p:nvSpPr>
-        <p:spPr>
-          <a:xfrm>
-            <a:off x="628650" y="365126"/>
-            <a:ext cx="7886700" cy="1103455"/>
-          </a:xfrm>
-        </p:spPr>
-        <p:txBody>
-          <a:bodyPr>
-            <a:noAutofit/>
-          </a:bodyPr>
-          <a:lstStyle/>
-          <a:p>
-            <a:pPr algn="ctr"/>
-            <a:r>
-              <a:rPr lang="en-US" sz="3200" b="1" dirty="0">
-                <a:latin typeface="+mn-lt"/>
-              </a:rPr>
-              <a:t>Phase 4</a:t>
-            </a:r>
-            <a:r>
-              <a:rPr lang="en-US" sz="3200" dirty="0">
-                <a:latin typeface="+mn-lt"/>
-              </a:rPr>
-              <a:t> – Success!</a:t>
-            </a:r>
-          </a:p>
-        </p:txBody>
-      </p:sp>
-      <p:sp>
-        <p:nvSpPr>
-          <p:cNvPr id="4" name="Slide Number Placeholder 3"/>
-          <p:cNvSpPr>
-            <a:spLocks noGrp="1"/>
-          </p:cNvSpPr>
-          <p:nvPr>
-            <p:ph type="sldNum" sz="quarter" idx="12"/>
-          </p:nvPr>
-        </p:nvSpPr>
-        <p:spPr/>
-        <p:txBody>
-          <a:bodyPr/>
-          <a:lstStyle/>
-          <a:p>
-            <a:fld id="{650AD656-6FF9-465D-B7B0-1CD0DD39CD23}" type="slidenum">
-              <a:rPr lang="en-US" smtClean="0"/>
-              <a:t>29</a:t>
-            </a:fld>
-            <a:endParaRPr lang="en-US"/>
-          </a:p>
-        </p:txBody>
-      </p:sp>
-      <p:pic>
-        <p:nvPicPr>
-          <p:cNvPr id="8" name="Picture 7">
-            <a:extLst>
-              <a:ext uri="{FF2B5EF4-FFF2-40B4-BE49-F238E27FC236}">
-                <a16:creationId xmlns:a16="http://schemas.microsoft.com/office/drawing/2014/main" id="{41FAFF94-5791-4651-A6A6-2B955BB40F74}"/>
-              </a:ext>
-            </a:extLst>
-          </p:cNvPr>
-          <p:cNvPicPr>
-            <a:picLocks noChangeAspect="1"/>
-          </p:cNvPicPr>
-          <p:nvPr/>
-        </p:nvPicPr>
-        <p:blipFill>
-          <a:blip r:embed="rId2"/>
-          <a:stretch>
-            <a:fillRect/>
-          </a:stretch>
-        </p:blipFill>
-        <p:spPr>
-          <a:xfrm>
-            <a:off x="1819619" y="1807704"/>
-            <a:ext cx="5504762" cy="4209524"/>
-          </a:xfrm>
-          <a:prstGeom prst="rect">
-            <a:avLst/>
-          </a:prstGeom>
-        </p:spPr>
-      </p:pic>
-    </p:spTree>
-    <p:extLst>
-      <p:ext uri="{BB962C8B-B14F-4D97-AF65-F5344CB8AC3E}">
-        <p14:creationId xmlns:p14="http://schemas.microsoft.com/office/powerpoint/2010/main" val="3193366687"/>
-      </p:ext>
-    </p:extLst>
-  </p:cSld>
-  <p:clrMapOvr>
-    <a:masterClrMapping/>
-  </p:clrMapOvr>
-</p:sld>
-</file>
-
 <file path=ppt/slides/slide3.xml><?xml version="1.0" encoding="utf-8"?>
 <p:sld xmlns:a="http://schemas.openxmlformats.org/drawingml/2006/main" xmlns:r="http://schemas.openxmlformats.org/officeDocument/2006/relationships" xmlns:p="http://schemas.openxmlformats.org/presentationml/2006/main">
   <p:cSld>
@@ -14351,7 +14664,7 @@
               <a:rPr lang="en-US" sz="2400" dirty="0">
                 <a:hlinkClick r:id="rId5" action="ppaction://hlinksldjump"/>
               </a:rPr>
-              <a:t>slide # 31</a:t>
+              <a:t>slide # 32</a:t>
             </a:r>
             <a:endParaRPr lang="en-US" sz="2400" dirty="0"/>
           </a:p>
@@ -14806,6 +15119,127 @@
           <a:chExt cx="0" cy="0"/>
         </a:xfrm>
       </p:grpSpPr>
+      <p:sp>
+        <p:nvSpPr>
+          <p:cNvPr id="2" name="Title 1"/>
+          <p:cNvSpPr>
+            <a:spLocks noGrp="1"/>
+          </p:cNvSpPr>
+          <p:nvPr>
+            <p:ph type="title"/>
+          </p:nvPr>
+        </p:nvSpPr>
+        <p:spPr>
+          <a:xfrm>
+            <a:off x="628650" y="365126"/>
+            <a:ext cx="7886700" cy="1103455"/>
+          </a:xfrm>
+        </p:spPr>
+        <p:txBody>
+          <a:bodyPr>
+            <a:noAutofit/>
+          </a:bodyPr>
+          <a:lstStyle/>
+          <a:p>
+            <a:pPr algn="ctr"/>
+            <a:r>
+              <a:rPr lang="en-US" sz="3200" b="1" dirty="0">
+                <a:latin typeface="+mn-lt"/>
+              </a:rPr>
+              <a:t>Phase 4</a:t>
+            </a:r>
+            <a:r>
+              <a:rPr lang="en-US" sz="3200" dirty="0">
+                <a:latin typeface="+mn-lt"/>
+              </a:rPr>
+              <a:t> – Success!</a:t>
+            </a:r>
+          </a:p>
+        </p:txBody>
+      </p:sp>
+      <p:sp>
+        <p:nvSpPr>
+          <p:cNvPr id="4" name="Slide Number Placeholder 3"/>
+          <p:cNvSpPr>
+            <a:spLocks noGrp="1"/>
+          </p:cNvSpPr>
+          <p:nvPr>
+            <p:ph type="sldNum" sz="quarter" idx="12"/>
+          </p:nvPr>
+        </p:nvSpPr>
+        <p:spPr/>
+        <p:txBody>
+          <a:bodyPr/>
+          <a:lstStyle/>
+          <a:p>
+            <a:fld id="{650AD656-6FF9-465D-B7B0-1CD0DD39CD23}" type="slidenum">
+              <a:rPr lang="en-US" smtClean="0"/>
+              <a:t>30</a:t>
+            </a:fld>
+            <a:endParaRPr lang="en-US"/>
+          </a:p>
+        </p:txBody>
+      </p:sp>
+      <p:pic>
+        <p:nvPicPr>
+          <p:cNvPr id="8" name="Picture 7">
+            <a:extLst>
+              <a:ext uri="{FF2B5EF4-FFF2-40B4-BE49-F238E27FC236}">
+                <a16:creationId xmlns:a16="http://schemas.microsoft.com/office/drawing/2014/main" id="{41FAFF94-5791-4651-A6A6-2B955BB40F74}"/>
+              </a:ext>
+            </a:extLst>
+          </p:cNvPr>
+          <p:cNvPicPr>
+            <a:picLocks noChangeAspect="1"/>
+          </p:cNvPicPr>
+          <p:nvPr/>
+        </p:nvPicPr>
+        <p:blipFill>
+          <a:blip r:embed="rId2"/>
+          <a:stretch>
+            <a:fillRect/>
+          </a:stretch>
+        </p:blipFill>
+        <p:spPr>
+          <a:xfrm>
+            <a:off x="1819619" y="1807704"/>
+            <a:ext cx="5504762" cy="4209524"/>
+          </a:xfrm>
+          <a:prstGeom prst="rect">
+            <a:avLst/>
+          </a:prstGeom>
+        </p:spPr>
+      </p:pic>
+    </p:spTree>
+    <p:extLst>
+      <p:ext uri="{BB962C8B-B14F-4D97-AF65-F5344CB8AC3E}">
+        <p14:creationId xmlns:p14="http://schemas.microsoft.com/office/powerpoint/2010/main" val="3193366687"/>
+      </p:ext>
+    </p:extLst>
+  </p:cSld>
+  <p:clrMapOvr>
+    <a:masterClrMapping/>
+  </p:clrMapOvr>
+</p:sld>
+</file>
+
+<file path=ppt/slides/slide31.xml><?xml version="1.0" encoding="utf-8"?>
+<p:sld xmlns:a="http://schemas.openxmlformats.org/drawingml/2006/main" xmlns:r="http://schemas.openxmlformats.org/officeDocument/2006/relationships" xmlns:p="http://schemas.openxmlformats.org/presentationml/2006/main">
+  <p:cSld>
+    <p:spTree>
+      <p:nvGrpSpPr>
+        <p:cNvPr id="1" name=""/>
+        <p:cNvGrpSpPr/>
+        <p:nvPr/>
+      </p:nvGrpSpPr>
+      <p:grpSpPr>
+        <a:xfrm>
+          <a:off x="0" y="0"/>
+          <a:ext cx="0" cy="0"/>
+          <a:chOff x="0" y="0"/>
+          <a:chExt cx="0" cy="0"/>
+        </a:xfrm>
+      </p:grpSpPr>
       <p:pic>
         <p:nvPicPr>
           <p:cNvPr id="7" name="Picture 6">
@@ -14896,7 +15330,7 @@
           <a:p>
             <a:fld id="{650AD656-6FF9-465D-B7B0-1CD0DD39CD23}" type="slidenum">
               <a:rPr lang="en-US" smtClean="0"/>
-              <a:t>30</a:t>
+              <a:t>31</a:t>
             </a:fld>
             <a:endParaRPr lang="en-US"/>
           </a:p>
@@ -15154,7 +15588,7 @@
 </p:sld>
 </file>
 
-<file path=ppt/slides/slide31.xml><?xml version="1.0" encoding="utf-8"?>
+<file path=ppt/slides/slide32.xml><?xml version="1.0" encoding="utf-8"?>
 <p:sld xmlns:a="http://schemas.openxmlformats.org/drawingml/2006/main" xmlns:r="http://schemas.openxmlformats.org/officeDocument/2006/relationships" xmlns:p="http://schemas.openxmlformats.org/presentationml/2006/main">
   <p:cSld>
     <p:spTree>
@@ -15303,7 +15737,7 @@
           <a:p>
             <a:fld id="{650AD656-6FF9-465D-B7B0-1CD0DD39CD23}" type="slidenum">
               <a:rPr lang="en-US" smtClean="0"/>
-              <a:t>31</a:t>
+              <a:t>32</a:t>
             </a:fld>
             <a:endParaRPr lang="en-US"/>
           </a:p>
@@ -15919,7 +16353,7 @@
 </p:sld>
 </file>
 
-<file path=ppt/slides/slide32.xml><?xml version="1.0" encoding="utf-8"?>
+<file path=ppt/slides/slide33.xml><?xml version="1.0" encoding="utf-8"?>
 <p:sld xmlns:a="http://schemas.openxmlformats.org/drawingml/2006/main" xmlns:r="http://schemas.openxmlformats.org/officeDocument/2006/relationships" xmlns:p="http://schemas.openxmlformats.org/presentationml/2006/main">
   <p:cSld>
     <p:spTree>
@@ -16091,7 +16525,7 @@
           <a:p>
             <a:fld id="{650AD656-6FF9-465D-B7B0-1CD0DD39CD23}" type="slidenum">
               <a:rPr lang="en-US" smtClean="0"/>
-              <a:t>32</a:t>
+              <a:t>33</a:t>
             </a:fld>
             <a:endParaRPr lang="en-US" dirty="0"/>
           </a:p>
@@ -16438,7 +16872,7 @@
 </p:sld>
 </file>
 
-<file path=ppt/slides/slide33.xml><?xml version="1.0" encoding="utf-8"?>
+<file path=ppt/slides/slide34.xml><?xml version="1.0" encoding="utf-8"?>
 <p:sld xmlns:a="http://schemas.openxmlformats.org/drawingml/2006/main" xmlns:r="http://schemas.openxmlformats.org/officeDocument/2006/relationships" xmlns:p="http://schemas.openxmlformats.org/presentationml/2006/main">
   <p:cSld>
     <p:spTree>
@@ -16642,7 +17076,7 @@
           <a:p>
             <a:fld id="{650AD656-6FF9-465D-B7B0-1CD0DD39CD23}" type="slidenum">
               <a:rPr lang="en-US" smtClean="0"/>
-              <a:t>33</a:t>
+              <a:t>34</a:t>
             </a:fld>
             <a:endParaRPr lang="en-US"/>
           </a:p>
@@ -16862,7 +17296,7 @@
 </p:sld>
 </file>
 
-<file path=ppt/slides/slide34.xml><?xml version="1.0" encoding="utf-8"?>
+<file path=ppt/slides/slide35.xml><?xml version="1.0" encoding="utf-8"?>
 <p:sld xmlns:a="http://schemas.openxmlformats.org/drawingml/2006/main" xmlns:r="http://schemas.openxmlformats.org/officeDocument/2006/relationships" xmlns:p="http://schemas.openxmlformats.org/presentationml/2006/main">
   <p:cSld>
     <p:spTree>
@@ -16964,7 +17398,7 @@
           <a:p>
             <a:fld id="{650AD656-6FF9-465D-B7B0-1CD0DD39CD23}" type="slidenum">
               <a:rPr lang="en-US" smtClean="0"/>
-              <a:t>34</a:t>
+              <a:t>35</a:t>
             </a:fld>
             <a:endParaRPr lang="en-US"/>
           </a:p>
@@ -17463,7 +17897,7 @@
 </p:sld>
 </file>
 
-<file path=ppt/slides/slide35.xml><?xml version="1.0" encoding="utf-8"?>
+<file path=ppt/slides/slide36.xml><?xml version="1.0" encoding="utf-8"?>
 <p:sld xmlns:a="http://schemas.openxmlformats.org/drawingml/2006/main" xmlns:r="http://schemas.openxmlformats.org/officeDocument/2006/relationships" xmlns:p="http://schemas.openxmlformats.org/presentationml/2006/main">
   <p:cSld>
     <p:spTree>
@@ -17705,7 +18139,7 @@
           <a:p>
             <a:fld id="{650AD656-6FF9-465D-B7B0-1CD0DD39CD23}" type="slidenum">
               <a:rPr lang="en-US" smtClean="0"/>
-              <a:t>35</a:t>
+              <a:t>36</a:t>
             </a:fld>
             <a:endParaRPr lang="en-US"/>
           </a:p>
@@ -18161,7 +18595,7 @@
 </p:sld>
 </file>
 
-<file path=ppt/slides/slide36.xml><?xml version="1.0" encoding="utf-8"?>
+<file path=ppt/slides/slide37.xml><?xml version="1.0" encoding="utf-8"?>
 <p:sld xmlns:a="http://schemas.openxmlformats.org/drawingml/2006/main" xmlns:r="http://schemas.openxmlformats.org/officeDocument/2006/relationships" xmlns:p="http://schemas.openxmlformats.org/presentationml/2006/main">
   <p:cSld>
     <p:spTree>
@@ -18268,7 +18702,7 @@
           <a:p>
             <a:fld id="{650AD656-6FF9-465D-B7B0-1CD0DD39CD23}" type="slidenum">
               <a:rPr lang="en-US" smtClean="0"/>
-              <a:t>36</a:t>
+              <a:t>37</a:t>
             </a:fld>
             <a:endParaRPr lang="en-US"/>
           </a:p>
@@ -18527,7 +18961,7 @@
 </p:sld>
 </file>
 
-<file path=ppt/slides/slide37.xml><?xml version="1.0" encoding="utf-8"?>
+<file path=ppt/slides/slide38.xml><?xml version="1.0" encoding="utf-8"?>
 <p:sld xmlns:a="http://schemas.openxmlformats.org/drawingml/2006/main" xmlns:r="http://schemas.openxmlformats.org/officeDocument/2006/relationships" xmlns:p="http://schemas.openxmlformats.org/presentationml/2006/main">
   <p:cSld>
     <p:spTree>
@@ -18599,7 +19033,7 @@
           <a:p>
             <a:fld id="{650AD656-6FF9-465D-B7B0-1CD0DD39CD23}" type="slidenum">
               <a:rPr lang="en-US" smtClean="0"/>
-              <a:t>37</a:t>
+              <a:t>38</a:t>
             </a:fld>
             <a:endParaRPr lang="en-US"/>
           </a:p>
@@ -18648,7 +19082,7 @@
 </p:sld>
 </file>
 
-<file path=ppt/slides/slide38.xml><?xml version="1.0" encoding="utf-8"?>
+<file path=ppt/slides/slide39.xml><?xml version="1.0" encoding="utf-8"?>
 <p:sld xmlns:a="http://schemas.openxmlformats.org/drawingml/2006/main" xmlns:r="http://schemas.openxmlformats.org/officeDocument/2006/relationships" xmlns:p="http://schemas.openxmlformats.org/presentationml/2006/main">
   <p:cSld>
     <p:spTree>
@@ -18755,7 +19189,7 @@
           <a:p>
             <a:fld id="{650AD656-6FF9-465D-B7B0-1CD0DD39CD23}" type="slidenum">
               <a:rPr lang="en-US" smtClean="0"/>
-              <a:t>38</a:t>
+              <a:t>39</a:t>
             </a:fld>
             <a:endParaRPr lang="en-US"/>
           </a:p>
@@ -19010,312 +19444,6 @@
       <p:bldP spid="8" grpId="0" animBg="1"/>
     </p:bldLst>
   </p:timing>
-</p:sld>
-</file>
-
-<file path=ppt/slides/slide39.xml><?xml version="1.0" encoding="utf-8"?>
-<p:sld xmlns:a="http://schemas.openxmlformats.org/drawingml/2006/main" xmlns:r="http://schemas.openxmlformats.org/officeDocument/2006/relationships" xmlns:p="http://schemas.openxmlformats.org/presentationml/2006/main">
-  <p:cSld>
-    <p:spTree>
-      <p:nvGrpSpPr>
-        <p:cNvPr id="1" name=""/>
-        <p:cNvGrpSpPr/>
-        <p:nvPr/>
-      </p:nvGrpSpPr>
-      <p:grpSpPr>
-        <a:xfrm>
-          <a:off x="0" y="0"/>
-          <a:ext cx="0" cy="0"/>
-          <a:chOff x="0" y="0"/>
-          <a:chExt cx="0" cy="0"/>
-        </a:xfrm>
-      </p:grpSpPr>
-      <p:pic>
-        <p:nvPicPr>
-          <p:cNvPr id="5" name="Picture 4">
-            <a:extLst>
-              <a:ext uri="{FF2B5EF4-FFF2-40B4-BE49-F238E27FC236}">
-                <a16:creationId xmlns:a16="http://schemas.microsoft.com/office/drawing/2014/main" id="{C4EF8DD7-204C-4595-8C20-94478E1612C3}"/>
-              </a:ext>
-            </a:extLst>
-          </p:cNvPr>
-          <p:cNvPicPr>
-            <a:picLocks noChangeAspect="1"/>
-          </p:cNvPicPr>
-          <p:nvPr/>
-        </p:nvPicPr>
-        <p:blipFill>
-          <a:blip r:embed="rId2"/>
-          <a:stretch>
-            <a:fillRect/>
-          </a:stretch>
-        </p:blipFill>
-        <p:spPr>
-          <a:xfrm>
-            <a:off x="1238562" y="2356491"/>
-            <a:ext cx="6666876" cy="4136383"/>
-          </a:xfrm>
-          <a:prstGeom prst="rect">
-            <a:avLst/>
-          </a:prstGeom>
-          <a:ln>
-            <a:solidFill>
-              <a:schemeClr val="tx1"/>
-            </a:solidFill>
-          </a:ln>
-        </p:spPr>
-      </p:pic>
-      <p:sp>
-        <p:nvSpPr>
-          <p:cNvPr id="2" name="Title 1"/>
-          <p:cNvSpPr>
-            <a:spLocks noGrp="1"/>
-          </p:cNvSpPr>
-          <p:nvPr>
-            <p:ph type="title"/>
-          </p:nvPr>
-        </p:nvSpPr>
-        <p:spPr>
-          <a:xfrm>
-            <a:off x="628650" y="365126"/>
-            <a:ext cx="7886700" cy="1103455"/>
-          </a:xfrm>
-        </p:spPr>
-        <p:txBody>
-          <a:bodyPr>
-            <a:noAutofit/>
-          </a:bodyPr>
-          <a:lstStyle/>
-          <a:p>
-            <a:pPr algn="ctr"/>
-            <a:r>
-              <a:rPr lang="en-US" sz="3200" b="1" dirty="0">
-                <a:latin typeface="+mn-lt"/>
-              </a:rPr>
-              <a:t>Viewing the Courseware Slides</a:t>
-            </a:r>
-            <a:endParaRPr lang="en-US" sz="3200" dirty="0">
-              <a:latin typeface="+mn-lt"/>
-            </a:endParaRPr>
-          </a:p>
-        </p:txBody>
-      </p:sp>
-      <p:sp>
-        <p:nvSpPr>
-          <p:cNvPr id="4" name="Slide Number Placeholder 3"/>
-          <p:cNvSpPr>
-            <a:spLocks noGrp="1"/>
-          </p:cNvSpPr>
-          <p:nvPr>
-            <p:ph type="sldNum" sz="quarter" idx="12"/>
-          </p:nvPr>
-        </p:nvSpPr>
-        <p:spPr/>
-        <p:txBody>
-          <a:bodyPr/>
-          <a:lstStyle/>
-          <a:p>
-            <a:fld id="{650AD656-6FF9-465D-B7B0-1CD0DD39CD23}" type="slidenum">
-              <a:rPr lang="en-US" smtClean="0"/>
-              <a:t>39</a:t>
-            </a:fld>
-            <a:endParaRPr lang="en-US"/>
-          </a:p>
-        </p:txBody>
-      </p:sp>
-      <p:sp>
-        <p:nvSpPr>
-          <p:cNvPr id="10" name="TextBox 9">
-            <a:extLst>
-              <a:ext uri="{FF2B5EF4-FFF2-40B4-BE49-F238E27FC236}">
-                <a16:creationId xmlns:a16="http://schemas.microsoft.com/office/drawing/2014/main" id="{421F8AB5-2C4A-4463-93DA-40D80FFC98CA}"/>
-              </a:ext>
-            </a:extLst>
-          </p:cNvPr>
-          <p:cNvSpPr txBox="1"/>
-          <p:nvPr/>
-        </p:nvSpPr>
-        <p:spPr>
-          <a:xfrm>
-            <a:off x="1238562" y="1398216"/>
-            <a:ext cx="6666876" cy="369332"/>
-          </a:xfrm>
-          <a:prstGeom prst="rect">
-            <a:avLst/>
-          </a:prstGeom>
-          <a:noFill/>
-        </p:spPr>
-        <p:txBody>
-          <a:bodyPr wrap="square" rtlCol="0">
-            <a:spAutoFit/>
-          </a:bodyPr>
-          <a:lstStyle/>
-          <a:p>
-            <a:pPr algn="ctr"/>
-            <a:r>
-              <a:rPr lang="en-US" sz="1800" b="1" dirty="0">
-                <a:solidFill>
-                  <a:srgbClr val="FF0000"/>
-                </a:solidFill>
-              </a:rPr>
-              <a:t>In a </a:t>
-            </a:r>
-            <a:r>
-              <a:rPr lang="en-US" sz="1800" b="1" u="sng" dirty="0">
-                <a:solidFill>
-                  <a:srgbClr val="FF0000"/>
-                </a:solidFill>
-              </a:rPr>
-              <a:t>new</a:t>
-            </a:r>
-            <a:r>
-              <a:rPr lang="en-US" sz="1800" b="1" dirty="0">
-                <a:solidFill>
-                  <a:srgbClr val="FF0000"/>
-                </a:solidFill>
-              </a:rPr>
-              <a:t> Terminal session, execute this command:</a:t>
-            </a:r>
-            <a:endParaRPr lang="en-US" b="1" dirty="0">
-              <a:solidFill>
-                <a:srgbClr val="FF0000"/>
-              </a:solidFill>
-            </a:endParaRPr>
-          </a:p>
-        </p:txBody>
-      </p:sp>
-      <p:sp>
-        <p:nvSpPr>
-          <p:cNvPr id="11" name="Content Placeholder 2">
-            <a:extLst>
-              <a:ext uri="{FF2B5EF4-FFF2-40B4-BE49-F238E27FC236}">
-                <a16:creationId xmlns:a16="http://schemas.microsoft.com/office/drawing/2014/main" id="{11BB7281-27F5-45AB-A4A8-3899C844D7D6}"/>
-              </a:ext>
-            </a:extLst>
-          </p:cNvPr>
-          <p:cNvSpPr>
-            <a:spLocks noGrp="1"/>
-          </p:cNvSpPr>
-          <p:nvPr>
-            <p:ph idx="1"/>
-          </p:nvPr>
-        </p:nvSpPr>
-        <p:spPr>
-          <a:xfrm>
-            <a:off x="1996971" y="1872095"/>
-            <a:ext cx="5150058" cy="473031"/>
-          </a:xfrm>
-        </p:spPr>
-        <p:txBody>
-          <a:bodyPr>
-            <a:noAutofit/>
-          </a:bodyPr>
-          <a:lstStyle/>
-          <a:p>
-            <a:pPr marL="0" indent="0" algn="ctr">
-              <a:spcBef>
-                <a:spcPts val="0"/>
-              </a:spcBef>
-              <a:spcAft>
-                <a:spcPts val="1200"/>
-              </a:spcAft>
-              <a:buClr>
-                <a:schemeClr val="tx1"/>
-              </a:buClr>
-              <a:buNone/>
-            </a:pPr>
-            <a:r>
-              <a:rPr lang="en-US" sz="2000" dirty="0" err="1">
-                <a:latin typeface="Consolas" panose="020B0609020204030204" pitchFamily="49" charset="0"/>
-              </a:rPr>
-              <a:t>xdg</a:t>
-            </a:r>
-            <a:r>
-              <a:rPr lang="en-US" sz="2000" dirty="0">
-                <a:latin typeface="Consolas" panose="020B0609020204030204" pitchFamily="49" charset="0"/>
-              </a:rPr>
-              <a:t>-open $HOME/</a:t>
-            </a:r>
-            <a:r>
-              <a:rPr lang="en-US" sz="2000" dirty="0" err="1">
-                <a:latin typeface="Consolas" panose="020B0609020204030204" pitchFamily="49" charset="0"/>
-              </a:rPr>
-              <a:t>scicomp</a:t>
-            </a:r>
-            <a:r>
-              <a:rPr lang="en-US" sz="2000" dirty="0">
-                <a:latin typeface="Consolas" panose="020B0609020204030204" pitchFamily="49" charset="0"/>
-              </a:rPr>
-              <a:t>-demos/slides</a:t>
-            </a:r>
-            <a:endParaRPr lang="en-US" sz="2400" dirty="0">
-              <a:latin typeface="Consolas" panose="020B0609020204030204" pitchFamily="49" charset="0"/>
-            </a:endParaRPr>
-          </a:p>
-        </p:txBody>
-      </p:sp>
-      <p:sp>
-        <p:nvSpPr>
-          <p:cNvPr id="9" name="Rectangle 8">
-            <a:extLst>
-              <a:ext uri="{FF2B5EF4-FFF2-40B4-BE49-F238E27FC236}">
-                <a16:creationId xmlns:a16="http://schemas.microsoft.com/office/drawing/2014/main" id="{B67E0145-D8DA-4627-BE04-26E92C5967ED}"/>
-              </a:ext>
-            </a:extLst>
-          </p:cNvPr>
-          <p:cNvSpPr/>
-          <p:nvPr/>
-        </p:nvSpPr>
-        <p:spPr>
-          <a:xfrm>
-            <a:off x="4362137" y="4092699"/>
-            <a:ext cx="2578309" cy="190358"/>
-          </a:xfrm>
-          <a:prstGeom prst="rect">
-            <a:avLst/>
-          </a:prstGeom>
-          <a:noFill/>
-          <a:ln w="38100">
-            <a:solidFill>
-              <a:srgbClr val="FF0000"/>
-            </a:solidFill>
-          </a:ln>
-        </p:spPr>
-        <p:style>
-          <a:lnRef idx="2">
-            <a:schemeClr val="accent1">
-              <a:shade val="50000"/>
-            </a:schemeClr>
-          </a:lnRef>
-          <a:fillRef idx="1">
-            <a:schemeClr val="accent1"/>
-          </a:fillRef>
-          <a:effectRef idx="0">
-            <a:schemeClr val="accent1"/>
-          </a:effectRef>
-          <a:fontRef idx="minor">
-            <a:schemeClr val="lt1"/>
-          </a:fontRef>
-        </p:style>
-        <p:txBody>
-          <a:bodyPr rtlCol="0" anchor="ctr"/>
-          <a:lstStyle/>
-          <a:p>
-            <a:pPr algn="ctr"/>
-            <a:endParaRPr lang="en-US"/>
-          </a:p>
-        </p:txBody>
-      </p:sp>
-    </p:spTree>
-    <p:extLst>
-      <p:ext uri="{BB962C8B-B14F-4D97-AF65-F5344CB8AC3E}">
-        <p14:creationId xmlns:p14="http://schemas.microsoft.com/office/powerpoint/2010/main" val="1835236079"/>
-      </p:ext>
-    </p:extLst>
-  </p:cSld>
-  <p:clrMapOvr>
-    <a:masterClrMapping/>
-  </p:clrMapOvr>
 </p:sld>
 </file>
 
@@ -20084,6 +20212,41 @@
           <a:chExt cx="0" cy="0"/>
         </a:xfrm>
       </p:grpSpPr>
+      <p:pic>
+        <p:nvPicPr>
+          <p:cNvPr id="5" name="Picture 4">
+            <a:extLst>
+              <a:ext uri="{FF2B5EF4-FFF2-40B4-BE49-F238E27FC236}">
+                <a16:creationId xmlns:a16="http://schemas.microsoft.com/office/drawing/2014/main" id="{C4EF8DD7-204C-4595-8C20-94478E1612C3}"/>
+              </a:ext>
+            </a:extLst>
+          </p:cNvPr>
+          <p:cNvPicPr>
+            <a:picLocks noChangeAspect="1"/>
+          </p:cNvPicPr>
+          <p:nvPr/>
+        </p:nvPicPr>
+        <p:blipFill>
+          <a:blip r:embed="rId2"/>
+          <a:stretch>
+            <a:fillRect/>
+          </a:stretch>
+        </p:blipFill>
+        <p:spPr>
+          <a:xfrm>
+            <a:off x="1238562" y="2356491"/>
+            <a:ext cx="6666876" cy="4136383"/>
+          </a:xfrm>
+          <a:prstGeom prst="rect">
+            <a:avLst/>
+          </a:prstGeom>
+          <a:ln>
+            <a:solidFill>
+              <a:schemeClr val="tx1"/>
+            </a:solidFill>
+          </a:ln>
+        </p:spPr>
+      </p:pic>
       <p:sp>
         <p:nvSpPr>
           <p:cNvPr id="2" name="Title 1"/>
@@ -20108,6 +20271,277 @@
           <a:p>
             <a:pPr algn="ctr"/>
             <a:r>
+              <a:rPr lang="en-US" sz="3200" b="1" dirty="0">
+                <a:latin typeface="+mn-lt"/>
+              </a:rPr>
+              <a:t>Viewing the Courseware Slides</a:t>
+            </a:r>
+            <a:endParaRPr lang="en-US" sz="3200" dirty="0">
+              <a:latin typeface="+mn-lt"/>
+            </a:endParaRPr>
+          </a:p>
+        </p:txBody>
+      </p:sp>
+      <p:sp>
+        <p:nvSpPr>
+          <p:cNvPr id="4" name="Slide Number Placeholder 3"/>
+          <p:cNvSpPr>
+            <a:spLocks noGrp="1"/>
+          </p:cNvSpPr>
+          <p:nvPr>
+            <p:ph type="sldNum" sz="quarter" idx="12"/>
+          </p:nvPr>
+        </p:nvSpPr>
+        <p:spPr/>
+        <p:txBody>
+          <a:bodyPr/>
+          <a:lstStyle/>
+          <a:p>
+            <a:fld id="{650AD656-6FF9-465D-B7B0-1CD0DD39CD23}" type="slidenum">
+              <a:rPr lang="en-US" smtClean="0"/>
+              <a:t>40</a:t>
+            </a:fld>
+            <a:endParaRPr lang="en-US"/>
+          </a:p>
+        </p:txBody>
+      </p:sp>
+      <p:sp>
+        <p:nvSpPr>
+          <p:cNvPr id="10" name="TextBox 9">
+            <a:extLst>
+              <a:ext uri="{FF2B5EF4-FFF2-40B4-BE49-F238E27FC236}">
+                <a16:creationId xmlns:a16="http://schemas.microsoft.com/office/drawing/2014/main" id="{421F8AB5-2C4A-4463-93DA-40D80FFC98CA}"/>
+              </a:ext>
+            </a:extLst>
+          </p:cNvPr>
+          <p:cNvSpPr txBox="1"/>
+          <p:nvPr/>
+        </p:nvSpPr>
+        <p:spPr>
+          <a:xfrm>
+            <a:off x="1238562" y="1398216"/>
+            <a:ext cx="6666876" cy="369332"/>
+          </a:xfrm>
+          <a:prstGeom prst="rect">
+            <a:avLst/>
+          </a:prstGeom>
+          <a:noFill/>
+        </p:spPr>
+        <p:txBody>
+          <a:bodyPr wrap="square" rtlCol="0">
+            <a:spAutoFit/>
+          </a:bodyPr>
+          <a:lstStyle/>
+          <a:p>
+            <a:pPr algn="ctr"/>
+            <a:r>
+              <a:rPr lang="en-US" sz="1800" b="1" dirty="0">
+                <a:solidFill>
+                  <a:srgbClr val="FF0000"/>
+                </a:solidFill>
+              </a:rPr>
+              <a:t>In a </a:t>
+            </a:r>
+            <a:r>
+              <a:rPr lang="en-US" sz="1800" b="1" u="sng" dirty="0">
+                <a:solidFill>
+                  <a:srgbClr val="FF0000"/>
+                </a:solidFill>
+              </a:rPr>
+              <a:t>new</a:t>
+            </a:r>
+            <a:r>
+              <a:rPr lang="en-US" sz="1800" b="1" dirty="0">
+                <a:solidFill>
+                  <a:srgbClr val="FF0000"/>
+                </a:solidFill>
+              </a:rPr>
+              <a:t> Terminal session, execute this command:</a:t>
+            </a:r>
+            <a:endParaRPr lang="en-US" b="1" dirty="0">
+              <a:solidFill>
+                <a:srgbClr val="FF0000"/>
+              </a:solidFill>
+            </a:endParaRPr>
+          </a:p>
+        </p:txBody>
+      </p:sp>
+      <p:sp>
+        <p:nvSpPr>
+          <p:cNvPr id="11" name="Content Placeholder 2">
+            <a:extLst>
+              <a:ext uri="{FF2B5EF4-FFF2-40B4-BE49-F238E27FC236}">
+                <a16:creationId xmlns:a16="http://schemas.microsoft.com/office/drawing/2014/main" id="{11BB7281-27F5-45AB-A4A8-3899C844D7D6}"/>
+              </a:ext>
+            </a:extLst>
+          </p:cNvPr>
+          <p:cNvSpPr>
+            <a:spLocks noGrp="1"/>
+          </p:cNvSpPr>
+          <p:nvPr>
+            <p:ph idx="1"/>
+          </p:nvPr>
+        </p:nvSpPr>
+        <p:spPr>
+          <a:xfrm>
+            <a:off x="1996971" y="1872095"/>
+            <a:ext cx="5150058" cy="473031"/>
+          </a:xfrm>
+        </p:spPr>
+        <p:txBody>
+          <a:bodyPr>
+            <a:noAutofit/>
+          </a:bodyPr>
+          <a:lstStyle/>
+          <a:p>
+            <a:pPr marL="0" indent="0" algn="ctr">
+              <a:spcBef>
+                <a:spcPts val="0"/>
+              </a:spcBef>
+              <a:spcAft>
+                <a:spcPts val="1200"/>
+              </a:spcAft>
+              <a:buClr>
+                <a:schemeClr val="tx1"/>
+              </a:buClr>
+              <a:buNone/>
+            </a:pPr>
+            <a:r>
+              <a:rPr lang="en-US" sz="2000" dirty="0" err="1">
+                <a:latin typeface="Consolas" panose="020B0609020204030204" pitchFamily="49" charset="0"/>
+              </a:rPr>
+              <a:t>xdg</a:t>
+            </a:r>
+            <a:r>
+              <a:rPr lang="en-US" sz="2000" dirty="0">
+                <a:latin typeface="Consolas" panose="020B0609020204030204" pitchFamily="49" charset="0"/>
+              </a:rPr>
+              <a:t>-open $HOME/</a:t>
+            </a:r>
+            <a:r>
+              <a:rPr lang="en-US" sz="2000" dirty="0" err="1">
+                <a:latin typeface="Consolas" panose="020B0609020204030204" pitchFamily="49" charset="0"/>
+              </a:rPr>
+              <a:t>scicomp</a:t>
+            </a:r>
+            <a:r>
+              <a:rPr lang="en-US" sz="2000" dirty="0">
+                <a:latin typeface="Consolas" panose="020B0609020204030204" pitchFamily="49" charset="0"/>
+              </a:rPr>
+              <a:t>-demos/slides</a:t>
+            </a:r>
+            <a:endParaRPr lang="en-US" sz="2400" dirty="0">
+              <a:latin typeface="Consolas" panose="020B0609020204030204" pitchFamily="49" charset="0"/>
+            </a:endParaRPr>
+          </a:p>
+        </p:txBody>
+      </p:sp>
+      <p:sp>
+        <p:nvSpPr>
+          <p:cNvPr id="9" name="Rectangle 8">
+            <a:extLst>
+              <a:ext uri="{FF2B5EF4-FFF2-40B4-BE49-F238E27FC236}">
+                <a16:creationId xmlns:a16="http://schemas.microsoft.com/office/drawing/2014/main" id="{B67E0145-D8DA-4627-BE04-26E92C5967ED}"/>
+              </a:ext>
+            </a:extLst>
+          </p:cNvPr>
+          <p:cNvSpPr/>
+          <p:nvPr/>
+        </p:nvSpPr>
+        <p:spPr>
+          <a:xfrm>
+            <a:off x="4362137" y="4092699"/>
+            <a:ext cx="2578309" cy="190358"/>
+          </a:xfrm>
+          <a:prstGeom prst="rect">
+            <a:avLst/>
+          </a:prstGeom>
+          <a:noFill/>
+          <a:ln w="38100">
+            <a:solidFill>
+              <a:srgbClr val="FF0000"/>
+            </a:solidFill>
+          </a:ln>
+        </p:spPr>
+        <p:style>
+          <a:lnRef idx="2">
+            <a:schemeClr val="accent1">
+              <a:shade val="50000"/>
+            </a:schemeClr>
+          </a:lnRef>
+          <a:fillRef idx="1">
+            <a:schemeClr val="accent1"/>
+          </a:fillRef>
+          <a:effectRef idx="0">
+            <a:schemeClr val="accent1"/>
+          </a:effectRef>
+          <a:fontRef idx="minor">
+            <a:schemeClr val="lt1"/>
+          </a:fontRef>
+        </p:style>
+        <p:txBody>
+          <a:bodyPr rtlCol="0" anchor="ctr"/>
+          <a:lstStyle/>
+          <a:p>
+            <a:pPr algn="ctr"/>
+            <a:endParaRPr lang="en-US"/>
+          </a:p>
+        </p:txBody>
+      </p:sp>
+    </p:spTree>
+    <p:extLst>
+      <p:ext uri="{BB962C8B-B14F-4D97-AF65-F5344CB8AC3E}">
+        <p14:creationId xmlns:p14="http://schemas.microsoft.com/office/powerpoint/2010/main" val="1835236079"/>
+      </p:ext>
+    </p:extLst>
+  </p:cSld>
+  <p:clrMapOvr>
+    <a:masterClrMapping/>
+  </p:clrMapOvr>
+</p:sld>
+</file>
+
+<file path=ppt/slides/slide41.xml><?xml version="1.0" encoding="utf-8"?>
+<p:sld xmlns:a="http://schemas.openxmlformats.org/drawingml/2006/main" xmlns:r="http://schemas.openxmlformats.org/officeDocument/2006/relationships" xmlns:p="http://schemas.openxmlformats.org/presentationml/2006/main">
+  <p:cSld>
+    <p:spTree>
+      <p:nvGrpSpPr>
+        <p:cNvPr id="1" name=""/>
+        <p:cNvGrpSpPr/>
+        <p:nvPr/>
+      </p:nvGrpSpPr>
+      <p:grpSpPr>
+        <a:xfrm>
+          <a:off x="0" y="0"/>
+          <a:ext cx="0" cy="0"/>
+          <a:chOff x="0" y="0"/>
+          <a:chExt cx="0" cy="0"/>
+        </a:xfrm>
+      </p:grpSpPr>
+      <p:sp>
+        <p:nvSpPr>
+          <p:cNvPr id="2" name="Title 1"/>
+          <p:cNvSpPr>
+            <a:spLocks noGrp="1"/>
+          </p:cNvSpPr>
+          <p:nvPr>
+            <p:ph type="title"/>
+          </p:nvPr>
+        </p:nvSpPr>
+        <p:spPr>
+          <a:xfrm>
+            <a:off x="628650" y="365126"/>
+            <a:ext cx="7886700" cy="1103455"/>
+          </a:xfrm>
+        </p:spPr>
+        <p:txBody>
+          <a:bodyPr>
+            <a:noAutofit/>
+          </a:bodyPr>
+          <a:lstStyle/>
+          <a:p>
+            <a:pPr algn="ctr"/>
+            <a:r>
               <a:rPr lang="en-US" sz="3200" dirty="0">
                 <a:latin typeface="+mn-lt"/>
               </a:rPr>
@@ -20447,7 +20881,7 @@
           <a:p>
             <a:fld id="{650AD656-6FF9-465D-B7B0-1CD0DD39CD23}" type="slidenum">
               <a:rPr lang="en-US" smtClean="0"/>
-              <a:t>40</a:t>
+              <a:t>41</a:t>
             </a:fld>
             <a:endParaRPr lang="en-US" dirty="0"/>
           </a:p>
@@ -20847,7 +21281,7 @@
 </p:sld>
 </file>
 
-<file path=ppt/slides/slide41.xml><?xml version="1.0" encoding="utf-8"?>
+<file path=ppt/slides/slide42.xml><?xml version="1.0" encoding="utf-8"?>
 <p:sld xmlns:a="http://schemas.openxmlformats.org/drawingml/2006/main" xmlns:r="http://schemas.openxmlformats.org/officeDocument/2006/relationships" xmlns:p="http://schemas.openxmlformats.org/presentationml/2006/main">
   <p:cSld>
     <p:spTree>
@@ -21111,7 +21545,7 @@
           <a:p>
             <a:fld id="{650AD656-6FF9-465D-B7B0-1CD0DD39CD23}" type="slidenum">
               <a:rPr lang="en-US" smtClean="0"/>
-              <a:t>41</a:t>
+              <a:t>42</a:t>
             </a:fld>
             <a:endParaRPr lang="en-US" dirty="0"/>
           </a:p>
@@ -21462,7 +21896,7 @@
 </p:sld>
 </file>
 
-<file path=ppt/slides/slide42.xml><?xml version="1.0" encoding="utf-8"?>
+<file path=ppt/slides/slide43.xml><?xml version="1.0" encoding="utf-8"?>
 <p:sld xmlns:a="http://schemas.openxmlformats.org/drawingml/2006/main" xmlns:r="http://schemas.openxmlformats.org/officeDocument/2006/relationships" xmlns:p="http://schemas.openxmlformats.org/presentationml/2006/main">
   <p:cSld>
     <p:spTree>
@@ -21659,7 +22093,7 @@
           <a:p>
             <a:fld id="{650AD656-6FF9-465D-B7B0-1CD0DD39CD23}" type="slidenum">
               <a:rPr lang="en-US" smtClean="0"/>
-              <a:t>42</a:t>
+              <a:t>43</a:t>
             </a:fld>
             <a:endParaRPr lang="en-US" dirty="0"/>
           </a:p>

</xml_diff>